<commit_message>
Updated lessons on compile time errors. Added tensor flow wrapper
</commit_message>
<xml_diff>
--- a/Teaching/Compile Time Errrors/compile_time_error_detection_overview.pptx
+++ b/Teaching/Compile Time Errrors/compile_time_error_detection_overview.pptx
@@ -4,6 +4,9 @@
   <p:sldMasterIdLst>
     <p:sldMasterId id="2147483648" r:id="rId1"/>
   </p:sldMasterIdLst>
+  <p:notesMasterIdLst>
+    <p:notesMasterId r:id="rId10"/>
+  </p:notesMasterIdLst>
   <p:sldIdLst>
     <p:sldId id="256" r:id="rId2"/>
     <p:sldId id="257" r:id="rId3"/>
@@ -14,10 +17,7 @@
     <p:sldId id="262" r:id="rId8"/>
     <p:sldId id="263" r:id="rId9"/>
   </p:sldIdLst>
-  <p:notesMasterIdLst>
-    <p:notesMasterId r:id="rId10"/>
-  </p:notesMasterIdLst>
-  <p:sldSz cx="9144000" cy="5143500"/>
+  <p:sldSz cx="9144000" cy="5143500" type="screen16x9"/>
   <p:notesSz cx="5143500" cy="9144000"/>
   <p:defaultTextStyle>
     <a:lvl1pPr marL="0" algn="l" defTabSz="914400" rtl="0" eaLnBrk="1" latinLnBrk="0" hangingPunct="1">
@@ -111,6 +111,11 @@
       </a:defRPr>
     </a:lvl9pPr>
   </p:defaultTextStyle>
+  <p:extLst>
+    <p:ext uri="{EFAFB233-063F-42B5-8137-9DF3F51BA10A}">
+      <p15:sldGuideLst xmlns:p15="http://schemas.microsoft.com/office/powerpoint/2012/main"/>
+    </p:ext>
+  </p:extLst>
 </p:presentation>
 </file>
 
@@ -136,234 +141,10 @@
           <a:chExt cx="0" cy="0"/>
         </a:xfrm>
       </p:grpSpPr>
-      <p:sp>
-        <p:nvSpPr>
-          <p:cNvPr id="2" name="Header Placeholder 1"/>
-          <p:cNvSpPr>
-            <a:spLocks noGrp="1"/>
-          </p:cNvSpPr>
-          <p:nvPr>
-            <p:ph type="hdr" sz="quarter"/>
-          </p:nvPr>
-        </p:nvSpPr>
-        <p:spPr>
-          <a:xfrm>
-            <a:off x="0" y="0"/>
-            <a:ext cx="2971800" cy="458788"/>
-          </a:xfrm>
-          <a:prstGeom prst="rect">
-            <a:avLst/>
-          </a:prstGeom>
-        </p:spPr>
-        <p:txBody>
-          <a:bodyPr vert="horz" lIns="91440" tIns="45720" rIns="91440" bIns="45720" rtlCol="0"/>
-          <a:lstStyle>
-            <a:lvl1pPr algn="l">
-              <a:defRPr sz="1200"/>
-            </a:lvl1pPr>
-          </a:lstStyle>
-          <a:p>
-            <a:endParaRPr lang="en-US"/>
-          </a:p>
-        </p:txBody>
-      </p:sp>
-      <p:sp>
-        <p:nvSpPr>
-          <p:cNvPr id="3" name="Date Placeholder 2"/>
-          <p:cNvSpPr>
-            <a:spLocks noGrp="1"/>
-          </p:cNvSpPr>
-          <p:nvPr>
-            <p:ph type="dt" idx="1"/>
-          </p:nvPr>
-        </p:nvSpPr>
-        <p:spPr>
-          <a:xfrm>
-            <a:off x="3884613" y="0"/>
-            <a:ext cx="2971800" cy="458788"/>
-          </a:xfrm>
-          <a:prstGeom prst="rect">
-            <a:avLst/>
-          </a:prstGeom>
-        </p:spPr>
-        <p:txBody>
-          <a:bodyPr vert="horz" lIns="91440" tIns="45720" rIns="91440" bIns="45720" rtlCol="0"/>
-          <a:lstStyle>
-            <a:lvl1pPr algn="r">
-              <a:defRPr sz="1200"/>
-            </a:lvl1pPr>
-          </a:lstStyle>
-          <a:p>
-            <a:fld id="{5282F153-3F37-0F45-9E97-73ACFA13230C}" type="datetimeFigureOut">
-              <a:rPr lang="en-US"/>
-              <a:t>7/23/19</a:t>
-            </a:fld>
-            <a:endParaRPr lang="en-US"/>
-          </a:p>
-        </p:txBody>
-      </p:sp>
-      <p:sp>
-        <p:nvSpPr>
-          <p:cNvPr id="4" name="Slide Image Placeholder 3"/>
-          <p:cNvSpPr>
-            <a:spLocks noGrp="1" noRot="1" noChangeAspect="1"/>
-          </p:cNvSpPr>
-          <p:nvPr>
-            <p:ph type="sldImg" idx="2"/>
-          </p:nvPr>
-        </p:nvSpPr>
-        <p:spPr>
-          <a:xfrm>
-            <a:off x="685800" y="1143000"/>
-            <a:ext cx="5486400" cy="3086100"/>
-          </a:xfrm>
-          <a:prstGeom prst="rect">
-            <a:avLst/>
-          </a:prstGeom>
-          <a:noFill/>
-          <a:ln w="12700">
-            <a:solidFill>
-              <a:prstClr val="black"/>
-            </a:solidFill>
-          </a:ln>
-        </p:spPr>
-        <p:txBody>
-          <a:bodyPr vert="horz" lIns="91440" tIns="45720" rIns="91440" bIns="45720" rtlCol="0" anchor="ctr"/>
-          <a:lstStyle/>
-          <a:p>
-            <a:endParaRPr lang="en-US"/>
-          </a:p>
-        </p:txBody>
-      </p:sp>
-      <p:sp>
-        <p:nvSpPr>
-          <p:cNvPr id="5" name="Notes Placeholder 4"/>
-          <p:cNvSpPr>
-            <a:spLocks noGrp="1"/>
-          </p:cNvSpPr>
-          <p:nvPr>
-            <p:ph type="body" sz="quarter" idx="3"/>
-          </p:nvPr>
-        </p:nvSpPr>
-        <p:spPr>
-          <a:xfrm>
-            <a:off x="685800" y="4400550"/>
-            <a:ext cx="5486400" cy="3600450"/>
-          </a:xfrm>
-          <a:prstGeom prst="rect">
-            <a:avLst/>
-          </a:prstGeom>
-        </p:spPr>
-        <p:txBody>
-          <a:bodyPr vert="horz" lIns="91440" tIns="45720" rIns="91440" bIns="45720" rtlCol="0"/>
-          <a:lstStyle/>
-          <a:p>
-            <a:pPr lvl="0"/>
-            <a:r>
-              <a:rPr lang="en-US"/>
-              <a:t>Click to edit Master text styles</a:t>
-            </a:r>
-          </a:p>
-          <a:p>
-            <a:pPr lvl="1"/>
-            <a:r>
-              <a:rPr lang="en-US"/>
-              <a:t>Second level</a:t>
-            </a:r>
-          </a:p>
-          <a:p>
-            <a:pPr lvl="2"/>
-            <a:r>
-              <a:rPr lang="en-US"/>
-              <a:t>Third level</a:t>
-            </a:r>
-          </a:p>
-          <a:p>
-            <a:pPr lvl="3"/>
-            <a:r>
-              <a:rPr lang="en-US"/>
-              <a:t>Fourth level</a:t>
-            </a:r>
-          </a:p>
-          <a:p>
-            <a:pPr lvl="4"/>
-            <a:r>
-              <a:rPr lang="en-US"/>
-              <a:t>Fifth level</a:t>
-            </a:r>
-          </a:p>
-        </p:txBody>
-      </p:sp>
-      <p:sp>
-        <p:nvSpPr>
-          <p:cNvPr id="6" name="Footer Placeholder 5"/>
-          <p:cNvSpPr>
-            <a:spLocks noGrp="1"/>
-          </p:cNvSpPr>
-          <p:nvPr>
-            <p:ph type="ftr" sz="quarter" idx="4"/>
-          </p:nvPr>
-        </p:nvSpPr>
-        <p:spPr>
-          <a:xfrm>
-            <a:off x="0" y="8685213"/>
-            <a:ext cx="2971800" cy="458787"/>
-          </a:xfrm>
-          <a:prstGeom prst="rect">
-            <a:avLst/>
-          </a:prstGeom>
-        </p:spPr>
-        <p:txBody>
-          <a:bodyPr vert="horz" lIns="91440" tIns="45720" rIns="91440" bIns="45720" rtlCol="0" anchor="b"/>
-          <a:lstStyle>
-            <a:lvl1pPr algn="l">
-              <a:defRPr sz="1200"/>
-            </a:lvl1pPr>
-          </a:lstStyle>
-          <a:p>
-            <a:endParaRPr lang="en-US"/>
-          </a:p>
-        </p:txBody>
-      </p:sp>
-      <p:sp>
-        <p:nvSpPr>
-          <p:cNvPr id="7" name="Slide Number Placeholder 6"/>
-          <p:cNvSpPr>
-            <a:spLocks noGrp="1"/>
-          </p:cNvSpPr>
-          <p:nvPr>
-            <p:ph type="sldNum" sz="quarter" idx="5"/>
-          </p:nvPr>
-        </p:nvSpPr>
-        <p:spPr>
-          <a:xfrm>
-            <a:off x="3884613" y="8685213"/>
-            <a:ext cx="2971800" cy="458787"/>
-          </a:xfrm>
-          <a:prstGeom prst="rect">
-            <a:avLst/>
-          </a:prstGeom>
-        </p:spPr>
-        <p:txBody>
-          <a:bodyPr vert="horz" lIns="91440" tIns="45720" rIns="91440" bIns="45720" rtlCol="0" anchor="b"/>
-          <a:lstStyle>
-            <a:lvl1pPr algn="r">
-              <a:defRPr sz="1200"/>
-            </a:lvl1pPr>
-          </a:lstStyle>
-          <a:p>
-            <a:fld id="{CE5E9CC1-C706-0F49-92D6-E571CC5EEA8F}" type="slidenum">
-              <a:rPr lang="en-US"/>
-              <a:t>‹#›</a:t>
-            </a:fld>
-            <a:endParaRPr lang="en-US"/>
-          </a:p>
-        </p:txBody>
-      </p:sp>
     </p:spTree>
     <p:extLst>
       <p:ext uri="{BB962C8B-B14F-4D97-AF65-F5344CB8AC3E}">
-        <p14:creationId xmlns:p14="http://schemas.microsoft.com/office/powerpoint/2010/main" val="1024086991"/>
+        <p14:creationId xmlns:p14="http://schemas.microsoft.com/office/powerpoint/2010/main" val="4166672836"/>
       </p:ext>
     </p:extLst>
   </p:cSld>
@@ -491,6 +272,13 @@
           </p:nvPr>
         </p:nvSpPr>
         <p:spPr/>
+        <p:txBody>
+          <a:bodyPr/>
+          <a:lstStyle/>
+          <a:p>
+            <a:endParaRPr lang="en-US"/>
+          </a:p>
+        </p:txBody>
       </p:sp>
       <p:sp>
         <p:nvSpPr>
@@ -507,10 +295,6 @@
           <a:bodyPr/>
           <a:lstStyle/>
           <a:p>
-            <a:r>
-              <a:rPr lang="en-US" dirty="0"/>
-              <a:t/>
-            </a:r>
             <a:endParaRPr lang="en-US" dirty="0"/>
           </a:p>
         </p:txBody>
@@ -579,6 +363,13 @@
           </p:nvPr>
         </p:nvSpPr>
         <p:spPr/>
+        <p:txBody>
+          <a:bodyPr/>
+          <a:lstStyle/>
+          <a:p>
+            <a:endParaRPr lang="en-US"/>
+          </a:p>
+        </p:txBody>
       </p:sp>
       <p:sp>
         <p:nvSpPr>
@@ -595,10 +386,6 @@
           <a:bodyPr/>
           <a:lstStyle/>
           <a:p>
-            <a:r>
-              <a:rPr lang="en-US" dirty="0"/>
-              <a:t/>
-            </a:r>
             <a:endParaRPr lang="en-US" dirty="0"/>
           </a:p>
         </p:txBody>
@@ -667,6 +454,13 @@
           </p:nvPr>
         </p:nvSpPr>
         <p:spPr/>
+        <p:txBody>
+          <a:bodyPr/>
+          <a:lstStyle/>
+          <a:p>
+            <a:endParaRPr lang="en-US"/>
+          </a:p>
+        </p:txBody>
       </p:sp>
       <p:sp>
         <p:nvSpPr>
@@ -683,10 +477,6 @@
           <a:bodyPr/>
           <a:lstStyle/>
           <a:p>
-            <a:r>
-              <a:rPr lang="en-US" dirty="0"/>
-              <a:t/>
-            </a:r>
             <a:endParaRPr lang="en-US" dirty="0"/>
           </a:p>
         </p:txBody>
@@ -755,6 +545,13 @@
           </p:nvPr>
         </p:nvSpPr>
         <p:spPr/>
+        <p:txBody>
+          <a:bodyPr/>
+          <a:lstStyle/>
+          <a:p>
+            <a:endParaRPr lang="en-US"/>
+          </a:p>
+        </p:txBody>
       </p:sp>
       <p:sp>
         <p:nvSpPr>
@@ -771,10 +568,6 @@
           <a:bodyPr/>
           <a:lstStyle/>
           <a:p>
-            <a:r>
-              <a:rPr lang="en-US" dirty="0"/>
-              <a:t/>
-            </a:r>
             <a:endParaRPr lang="en-US" dirty="0"/>
           </a:p>
         </p:txBody>
@@ -843,6 +636,13 @@
           </p:nvPr>
         </p:nvSpPr>
         <p:spPr/>
+        <p:txBody>
+          <a:bodyPr/>
+          <a:lstStyle/>
+          <a:p>
+            <a:endParaRPr lang="en-US"/>
+          </a:p>
+        </p:txBody>
       </p:sp>
       <p:sp>
         <p:nvSpPr>
@@ -859,10 +659,6 @@
           <a:bodyPr/>
           <a:lstStyle/>
           <a:p>
-            <a:r>
-              <a:rPr lang="en-US" dirty="0"/>
-              <a:t/>
-            </a:r>
             <a:endParaRPr lang="en-US" dirty="0"/>
           </a:p>
         </p:txBody>
@@ -931,6 +727,13 @@
           </p:nvPr>
         </p:nvSpPr>
         <p:spPr/>
+        <p:txBody>
+          <a:bodyPr/>
+          <a:lstStyle/>
+          <a:p>
+            <a:endParaRPr lang="en-US"/>
+          </a:p>
+        </p:txBody>
       </p:sp>
       <p:sp>
         <p:nvSpPr>
@@ -947,10 +750,6 @@
           <a:bodyPr/>
           <a:lstStyle/>
           <a:p>
-            <a:r>
-              <a:rPr lang="en-US" dirty="0"/>
-              <a:t/>
-            </a:r>
             <a:endParaRPr lang="en-US" dirty="0"/>
           </a:p>
         </p:txBody>
@@ -1019,6 +818,13 @@
           </p:nvPr>
         </p:nvSpPr>
         <p:spPr/>
+        <p:txBody>
+          <a:bodyPr/>
+          <a:lstStyle/>
+          <a:p>
+            <a:endParaRPr lang="en-US"/>
+          </a:p>
+        </p:txBody>
       </p:sp>
       <p:sp>
         <p:nvSpPr>
@@ -1035,10 +841,6 @@
           <a:bodyPr/>
           <a:lstStyle/>
           <a:p>
-            <a:r>
-              <a:rPr lang="en-US" dirty="0"/>
-              <a:t/>
-            </a:r>
             <a:endParaRPr lang="en-US" dirty="0"/>
           </a:p>
         </p:txBody>
@@ -1107,6 +909,13 @@
           </p:nvPr>
         </p:nvSpPr>
         <p:spPr/>
+        <p:txBody>
+          <a:bodyPr/>
+          <a:lstStyle/>
+          <a:p>
+            <a:endParaRPr lang="en-US"/>
+          </a:p>
+        </p:txBody>
       </p:sp>
       <p:sp>
         <p:nvSpPr>
@@ -1123,10 +932,6 @@
           <a:bodyPr/>
           <a:lstStyle/>
           <a:p>
-            <a:r>
-              <a:rPr lang="en-US" dirty="0"/>
-              <a:t/>
-            </a:r>
             <a:endParaRPr lang="en-US" dirty="0"/>
           </a:p>
         </p:txBody>
@@ -1200,6 +1005,11 @@
 <file path=ppt/slideMasters/slideMaster1.xml><?xml version="1.0" encoding="utf-8"?>
 <p:sldMaster xmlns:a="http://schemas.openxmlformats.org/drawingml/2006/main" xmlns:r="http://schemas.openxmlformats.org/officeDocument/2006/relationships" xmlns:p="http://schemas.openxmlformats.org/presentationml/2006/main">
   <p:cSld>
+    <p:bg>
+      <p:bgRef idx="1001">
+        <a:schemeClr val="bg1"/>
+      </p:bgRef>
+    </p:bg>
     <p:spTree>
       <p:nvGrpSpPr>
         <p:cNvPr id="1" name=""/>
@@ -1482,6 +1292,7 @@
         <a:solidFill>
           <a:srgbClr val="0D1117"/>
         </a:solidFill>
+        <a:effectLst/>
       </p:bgPr>
     </p:bg>
     <p:spTree>
@@ -1519,7 +1330,7 @@
           <a:bodyPr wrap="square" rtlCol="0" anchor="ctr"/>
           <a:lstStyle/>
           <a:p>
-            <a:pPr algn="ctr" indent="0" marL="0">
+            <a:pPr marL="0" indent="0" algn="ctr">
               <a:buNone/>
             </a:pPr>
             <a:r>
@@ -1558,7 +1369,7 @@
           <a:bodyPr wrap="square" rtlCol="0" anchor="ctr"/>
           <a:lstStyle/>
           <a:p>
-            <a:pPr algn="ctr" indent="0" marL="0">
+            <a:pPr marL="0" indent="0" algn="ctr">
               <a:buNone/>
             </a:pPr>
             <a:r>
@@ -1595,6 +1406,13 @@
           </a:solidFill>
           <a:ln/>
         </p:spPr>
+        <p:txBody>
+          <a:bodyPr/>
+          <a:lstStyle/>
+          <a:p>
+            <a:endParaRPr/>
+          </a:p>
+        </p:txBody>
       </p:sp>
       <p:sp>
         <p:nvSpPr>
@@ -1617,7 +1435,7 @@
           <a:bodyPr wrap="square" rtlCol="0" anchor="ctr"/>
           <a:lstStyle/>
           <a:p>
-            <a:pPr algn="ctr" indent="0" marL="0">
+            <a:pPr marL="0" indent="0" algn="ctr">
               <a:buNone/>
             </a:pPr>
             <a:r>
@@ -1648,6 +1466,7 @@
         <a:solidFill>
           <a:srgbClr val="0D1117"/>
         </a:solidFill>
+        <a:effectLst/>
       </p:bgPr>
     </p:bg>
     <p:spTree>
@@ -1685,7 +1504,7 @@
           <a:bodyPr wrap="square" rtlCol="0" anchor="ctr"/>
           <a:lstStyle/>
           <a:p>
-            <a:pPr indent="0" marL="0">
+            <a:pPr marL="0" indent="0">
               <a:buNone/>
             </a:pPr>
             <a:r>
@@ -1724,7 +1543,7 @@
           <a:bodyPr wrap="square" rtlCol="0" anchor="ctr"/>
           <a:lstStyle/>
           <a:p>
-            <a:pPr indent="0" marL="0">
+            <a:pPr marL="0" indent="0">
               <a:buNone/>
             </a:pPr>
             <a:r>
@@ -1763,7 +1582,7 @@
           <a:bodyPr wrap="square" rtlCol="0" anchor="ctr"/>
           <a:lstStyle/>
           <a:p>
-            <a:pPr indent="0" marL="0">
+            <a:pPr marL="0" indent="0">
               <a:buNone/>
             </a:pPr>
             <a:r>
@@ -1802,7 +1621,7 @@
           <a:bodyPr wrap="square" rtlCol="0" anchor="ctr"/>
           <a:lstStyle/>
           <a:p>
-            <a:pPr indent="0" marL="0">
+            <a:pPr marL="0" indent="0">
               <a:buNone/>
             </a:pPr>
             <a:r>
@@ -1841,7 +1660,7 @@
           <a:bodyPr wrap="square" rtlCol="0" anchor="ctr"/>
           <a:lstStyle/>
           <a:p>
-            <a:pPr indent="0" marL="0">
+            <a:pPr marL="0" indent="0">
               <a:buNone/>
             </a:pPr>
             <a:r>
@@ -1880,7 +1699,7 @@
           <a:bodyPr wrap="square" rtlCol="0" anchor="ctr"/>
           <a:lstStyle/>
           <a:p>
-            <a:pPr indent="0" marL="0">
+            <a:pPr marL="0" indent="0">
               <a:buNone/>
             </a:pPr>
             <a:r>
@@ -1922,6 +1741,13 @@
             <a:prstDash val="solid"/>
           </a:ln>
         </p:spPr>
+        <p:txBody>
+          <a:bodyPr/>
+          <a:lstStyle/>
+          <a:p>
+            <a:endParaRPr/>
+          </a:p>
+        </p:txBody>
       </p:sp>
       <p:sp>
         <p:nvSpPr>
@@ -1942,6 +1768,13 @@
           </a:solidFill>
           <a:ln/>
         </p:spPr>
+        <p:txBody>
+          <a:bodyPr/>
+          <a:lstStyle/>
+          <a:p>
+            <a:endParaRPr/>
+          </a:p>
+        </p:txBody>
       </p:sp>
       <p:sp>
         <p:nvSpPr>
@@ -1964,7 +1797,7 @@
           <a:bodyPr wrap="square" rtlCol="0" anchor="ctr"/>
           <a:lstStyle/>
           <a:p>
-            <a:pPr indent="0" marL="0">
+            <a:pPr marL="0" indent="0">
               <a:buNone/>
             </a:pPr>
             <a:r>
@@ -2003,21 +1836,14 @@
           <a:bodyPr wrap="square" rtlCol="0" anchor="t"/>
           <a:lstStyle/>
           <a:p>
-            <a:pPr indent="0" marL="0">
-              <a:buNone/>
-            </a:pPr>
-            <a:r>
-              <a:rPr lang="en-US" sz="1000" dirty="0">
-                <a:solidFill>
-                  <a:srgbClr val="E6EDF3"/>
-                </a:solidFill>
-                <a:latin typeface="Arial" pitchFamily="34" charset="0"/>
-                <a:ea typeface="Arial" pitchFamily="34" charset="-122"/>
-                <a:cs typeface="Arial" pitchFamily="34" charset="-120"/>
-              </a:rPr>
-              <a:t>Transform runtime errors into compile errors—making entire classes of bugs impossible to write.</a:t>
-            </a:r>
-            <a:endParaRPr lang="en-US" sz="1000" dirty="0"/>
+            <a:r>
+              <a:rPr dirty="0">
+                <a:solidFill>
+                  <a:schemeClr val="bg2"/>
+                </a:solidFill>
+              </a:rPr>
+              <a:t>Transform runtime errors into compile errors—making many classes of bugs hard or impossible to write.</a:t>
+            </a:r>
           </a:p>
         </p:txBody>
       </p:sp>
@@ -2037,6 +1863,7 @@
         <a:solidFill>
           <a:srgbClr val="0D1117"/>
         </a:solidFill>
+        <a:effectLst/>
       </p:bgPr>
     </p:bg>
     <p:spTree>
@@ -2055,45 +1882,6 @@
       </p:grpSpPr>
       <p:sp>
         <p:nvSpPr>
-          <p:cNvPr id="2" name="Text 0"/>
-          <p:cNvSpPr/>
-          <p:nvPr/>
-        </p:nvSpPr>
-        <p:spPr>
-          <a:xfrm>
-            <a:off x="365760" y="274320"/>
-            <a:ext cx="8412480" cy="548640"/>
-          </a:xfrm>
-          <a:prstGeom prst="rect">
-            <a:avLst/>
-          </a:prstGeom>
-          <a:noFill/>
-          <a:ln/>
-        </p:spPr>
-        <p:txBody>
-          <a:bodyPr wrap="square" rtlCol="0" anchor="ctr"/>
-          <a:lstStyle/>
-          <a:p>
-            <a:pPr indent="0" marL="0">
-              <a:buNone/>
-            </a:pPr>
-            <a:r>
-              <a:rPr lang="en-US" sz="2800" b="1" dirty="0">
-                <a:solidFill>
-                  <a:srgbClr val="E6EDF3"/>
-                </a:solidFill>
-                <a:latin typeface="Arial" pitchFamily="34" charset="0"/>
-                <a:ea typeface="Arial" pitchFamily="34" charset="-122"/>
-                <a:cs typeface="Arial" pitchFamily="34" charset="-120"/>
-              </a:rPr>
-              <a:t>Session 1: Strong Typedefs</a:t>
-            </a:r>
-            <a:endParaRPr lang="en-US" sz="2800" dirty="0"/>
-          </a:p>
-        </p:txBody>
-      </p:sp>
-      <p:sp>
-        <p:nvSpPr>
           <p:cNvPr id="3" name="Shape 1"/>
           <p:cNvSpPr/>
           <p:nvPr/>
@@ -2111,6 +1899,13 @@
           </a:solidFill>
           <a:ln/>
         </p:spPr>
+        <p:txBody>
+          <a:bodyPr/>
+          <a:lstStyle/>
+          <a:p>
+            <a:endParaRPr/>
+          </a:p>
+        </p:txBody>
       </p:sp>
       <p:sp>
         <p:nvSpPr>
@@ -2133,7 +1928,7 @@
           <a:bodyPr wrap="square" rtlCol="0" anchor="ctr"/>
           <a:lstStyle/>
           <a:p>
-            <a:pPr algn="ctr" indent="0" marL="0">
+            <a:pPr marL="0" indent="0" algn="ctr">
               <a:buNone/>
             </a:pPr>
             <a:r>
@@ -2169,7 +1964,7 @@
           <a:bodyPr wrap="square" rtlCol="0" anchor="ctr"/>
           <a:lstStyle/>
           <a:p>
-            <a:pPr indent="0" marL="0">
+            <a:pPr marL="0" indent="0">
               <a:buNone/>
             </a:pPr>
             <a:r>
@@ -2205,7 +2000,7 @@
           <a:bodyPr wrap="square" rtlCol="0" anchor="ctr"/>
           <a:lstStyle/>
           <a:p>
-            <a:pPr indent="0" marL="0">
+            <a:pPr marL="0" indent="0">
               <a:buNone/>
             </a:pPr>
             <a:r>
@@ -2244,6 +2039,13 @@
             <a:prstDash val="solid"/>
           </a:ln>
         </p:spPr>
+        <p:txBody>
+          <a:bodyPr/>
+          <a:lstStyle/>
+          <a:p>
+            <a:endParaRPr/>
+          </a:p>
+        </p:txBody>
       </p:sp>
       <p:sp>
         <p:nvSpPr>
@@ -2264,6 +2066,13 @@
           </a:solidFill>
           <a:ln/>
         </p:spPr>
+        <p:txBody>
+          <a:bodyPr/>
+          <a:lstStyle/>
+          <a:p>
+            <a:endParaRPr/>
+          </a:p>
+        </p:txBody>
       </p:sp>
       <p:sp>
         <p:nvSpPr>
@@ -2286,7 +2095,7 @@
           <a:bodyPr wrap="square" rtlCol="0" anchor="t"/>
           <a:lstStyle/>
           <a:p>
-            <a:pPr indent="0" marL="0">
+            <a:pPr marL="0" indent="0">
               <a:buNone/>
             </a:pPr>
             <a:r>
@@ -2303,7 +2112,7 @@
             <a:endParaRPr lang="en-US" sz="900" dirty="0"/>
           </a:p>
           <a:p>
-            <a:pPr indent="0" marL="0">
+            <a:pPr marL="0" indent="0">
               <a:buNone/>
             </a:pPr>
             <a:r>
@@ -2320,7 +2129,7 @@
             <a:endParaRPr lang="en-US" sz="900" dirty="0"/>
           </a:p>
           <a:p>
-            <a:pPr indent="0" marL="0">
+            <a:pPr marL="0" indent="0">
               <a:buNone/>
             </a:pPr>
             <a:r>
@@ -2337,7 +2146,7 @@
             <a:endParaRPr lang="en-US" sz="900" dirty="0"/>
           </a:p>
           <a:p>
-            <a:pPr indent="0" marL="0">
+            <a:pPr marL="0" indent="0">
               <a:buNone/>
             </a:pPr>
             <a:r>
@@ -2376,7 +2185,7 @@
           <a:bodyPr wrap="square" rtlCol="0" anchor="ctr"/>
           <a:lstStyle/>
           <a:p>
-            <a:pPr indent="0" marL="0">
+            <a:pPr marL="0" indent="0">
               <a:buNone/>
             </a:pPr>
             <a:r>
@@ -2415,6 +2224,13 @@
             <a:prstDash val="solid"/>
           </a:ln>
         </p:spPr>
+        <p:txBody>
+          <a:bodyPr/>
+          <a:lstStyle/>
+          <a:p>
+            <a:endParaRPr/>
+          </a:p>
+        </p:txBody>
       </p:sp>
       <p:sp>
         <p:nvSpPr>
@@ -2435,6 +2251,13 @@
           </a:solidFill>
           <a:ln/>
         </p:spPr>
+        <p:txBody>
+          <a:bodyPr/>
+          <a:lstStyle/>
+          <a:p>
+            <a:endParaRPr/>
+          </a:p>
+        </p:txBody>
       </p:sp>
       <p:sp>
         <p:nvSpPr>
@@ -2457,7 +2280,7 @@
           <a:bodyPr wrap="square" rtlCol="0" anchor="t"/>
           <a:lstStyle/>
           <a:p>
-            <a:pPr indent="0" marL="0">
+            <a:pPr marL="0" indent="0">
               <a:buNone/>
             </a:pPr>
             <a:r>
@@ -2474,7 +2297,7 @@
             <a:endParaRPr lang="en-US" sz="900" dirty="0"/>
           </a:p>
           <a:p>
-            <a:pPr indent="0" marL="0">
+            <a:pPr marL="0" indent="0">
               <a:buNone/>
             </a:pPr>
             <a:r>
@@ -2491,7 +2314,7 @@
             <a:endParaRPr lang="en-US" sz="900" dirty="0"/>
           </a:p>
           <a:p>
-            <a:pPr indent="0" marL="0">
+            <a:pPr marL="0" indent="0">
               <a:buNone/>
             </a:pPr>
             <a:r>
@@ -2530,7 +2353,7 @@
           <a:bodyPr wrap="square" rtlCol="0" anchor="ctr"/>
           <a:lstStyle/>
           <a:p>
-            <a:pPr indent="0" marL="0">
+            <a:pPr marL="0" indent="0">
               <a:buNone/>
             </a:pPr>
             <a:r>
@@ -2566,7 +2389,7 @@
           <a:bodyPr wrap="square" rtlCol="0" anchor="ctr"/>
           <a:lstStyle/>
           <a:p>
-            <a:pPr indent="0" marL="0">
+            <a:pPr marL="0" indent="0">
               <a:buNone/>
             </a:pPr>
             <a:r>
@@ -2602,7 +2425,7 @@
           <a:bodyPr wrap="square" rtlCol="0" anchor="ctr"/>
           <a:lstStyle/>
           <a:p>
-            <a:pPr indent="0" marL="0">
+            <a:pPr marL="0" indent="0">
               <a:buNone/>
             </a:pPr>
             <a:r>
@@ -2638,7 +2461,7 @@
           <a:bodyPr wrap="square" rtlCol="0" anchor="ctr"/>
           <a:lstStyle/>
           <a:p>
-            <a:pPr indent="0" marL="0">
+            <a:pPr marL="0" indent="0">
               <a:buNone/>
             </a:pPr>
             <a:r>
@@ -2677,6 +2500,13 @@
             <a:prstDash val="solid"/>
           </a:ln>
         </p:spPr>
+        <p:txBody>
+          <a:bodyPr/>
+          <a:lstStyle/>
+          <a:p>
+            <a:endParaRPr/>
+          </a:p>
+        </p:txBody>
       </p:sp>
       <p:sp>
         <p:nvSpPr>
@@ -2697,6 +2527,13 @@
           </a:solidFill>
           <a:ln/>
         </p:spPr>
+        <p:txBody>
+          <a:bodyPr/>
+          <a:lstStyle/>
+          <a:p>
+            <a:endParaRPr/>
+          </a:p>
+        </p:txBody>
       </p:sp>
       <p:sp>
         <p:nvSpPr>
@@ -2719,7 +2556,7 @@
           <a:bodyPr wrap="square" rtlCol="0" anchor="ctr"/>
           <a:lstStyle/>
           <a:p>
-            <a:pPr indent="0" marL="0">
+            <a:pPr marL="0" indent="0">
               <a:buNone/>
             </a:pPr>
             <a:r>
@@ -2758,7 +2595,7 @@
           <a:bodyPr wrap="square" rtlCol="0" anchor="t"/>
           <a:lstStyle/>
           <a:p>
-            <a:pPr indent="0" marL="0">
+            <a:pPr marL="0" indent="0">
               <a:buNone/>
             </a:pPr>
             <a:r>
@@ -2792,6 +2629,7 @@
         <a:solidFill>
           <a:srgbClr val="0D1117"/>
         </a:solidFill>
+        <a:effectLst/>
       </p:bgPr>
     </p:bg>
     <p:spTree>
@@ -2810,45 +2648,6 @@
       </p:grpSpPr>
       <p:sp>
         <p:nvSpPr>
-          <p:cNvPr id="2" name="Text 0"/>
-          <p:cNvSpPr/>
-          <p:nvPr/>
-        </p:nvSpPr>
-        <p:spPr>
-          <a:xfrm>
-            <a:off x="365760" y="274320"/>
-            <a:ext cx="8412480" cy="548640"/>
-          </a:xfrm>
-          <a:prstGeom prst="rect">
-            <a:avLst/>
-          </a:prstGeom>
-          <a:noFill/>
-          <a:ln/>
-        </p:spPr>
-        <p:txBody>
-          <a:bodyPr wrap="square" rtlCol="0" anchor="ctr"/>
-          <a:lstStyle/>
-          <a:p>
-            <a:pPr indent="0" marL="0">
-              <a:buNone/>
-            </a:pPr>
-            <a:r>
-              <a:rPr lang="en-US" sz="2800" b="1" dirty="0">
-                <a:solidFill>
-                  <a:srgbClr val="E6EDF3"/>
-                </a:solidFill>
-                <a:latin typeface="Arial" pitchFamily="34" charset="0"/>
-                <a:ea typeface="Arial" pitchFamily="34" charset="-122"/>
-                <a:cs typeface="Arial" pitchFamily="34" charset="-120"/>
-              </a:rPr>
-              <a:t>Session 2: Exhaustive Enums</a:t>
-            </a:r>
-            <a:endParaRPr lang="en-US" sz="2800" dirty="0"/>
-          </a:p>
-        </p:txBody>
-      </p:sp>
-      <p:sp>
-        <p:nvSpPr>
           <p:cNvPr id="3" name="Shape 1"/>
           <p:cNvSpPr/>
           <p:nvPr/>
@@ -2866,6 +2665,13 @@
           </a:solidFill>
           <a:ln/>
         </p:spPr>
+        <p:txBody>
+          <a:bodyPr/>
+          <a:lstStyle/>
+          <a:p>
+            <a:endParaRPr/>
+          </a:p>
+        </p:txBody>
       </p:sp>
       <p:sp>
         <p:nvSpPr>
@@ -2888,7 +2694,7 @@
           <a:bodyPr wrap="square" rtlCol="0" anchor="ctr"/>
           <a:lstStyle/>
           <a:p>
-            <a:pPr algn="ctr" indent="0" marL="0">
+            <a:pPr marL="0" indent="0" algn="ctr">
               <a:buNone/>
             </a:pPr>
             <a:r>
@@ -2924,7 +2730,7 @@
           <a:bodyPr wrap="square" rtlCol="0" anchor="ctr"/>
           <a:lstStyle/>
           <a:p>
-            <a:pPr indent="0" marL="0">
+            <a:pPr marL="0" indent="0">
               <a:buNone/>
             </a:pPr>
             <a:r>
@@ -2960,7 +2766,7 @@
           <a:bodyPr wrap="square" rtlCol="0" anchor="ctr"/>
           <a:lstStyle/>
           <a:p>
-            <a:pPr indent="0" marL="0">
+            <a:pPr marL="0" indent="0">
               <a:buNone/>
             </a:pPr>
             <a:r>
@@ -2999,6 +2805,13 @@
             <a:prstDash val="solid"/>
           </a:ln>
         </p:spPr>
+        <p:txBody>
+          <a:bodyPr/>
+          <a:lstStyle/>
+          <a:p>
+            <a:endParaRPr/>
+          </a:p>
+        </p:txBody>
       </p:sp>
       <p:sp>
         <p:nvSpPr>
@@ -3019,6 +2832,13 @@
           </a:solidFill>
           <a:ln/>
         </p:spPr>
+        <p:txBody>
+          <a:bodyPr/>
+          <a:lstStyle/>
+          <a:p>
+            <a:endParaRPr/>
+          </a:p>
+        </p:txBody>
       </p:sp>
       <p:sp>
         <p:nvSpPr>
@@ -3041,7 +2861,7 @@
           <a:bodyPr wrap="square" rtlCol="0" anchor="t"/>
           <a:lstStyle/>
           <a:p>
-            <a:pPr indent="0" marL="0">
+            <a:pPr marL="0" indent="0">
               <a:buNone/>
             </a:pPr>
             <a:r>
@@ -3058,7 +2878,7 @@
             <a:endParaRPr lang="en-US" sz="900" dirty="0"/>
           </a:p>
           <a:p>
-            <a:pPr indent="0" marL="0">
+            <a:pPr marL="0" indent="0">
               <a:buNone/>
             </a:pPr>
             <a:r>
@@ -3075,7 +2895,7 @@
             <a:endParaRPr lang="en-US" sz="900" dirty="0"/>
           </a:p>
           <a:p>
-            <a:pPr indent="0" marL="0">
+            <a:pPr marL="0" indent="0">
               <a:buNone/>
             </a:pPr>
             <a:r>
@@ -3092,7 +2912,7 @@
             <a:endParaRPr lang="en-US" sz="900" dirty="0"/>
           </a:p>
           <a:p>
-            <a:pPr indent="0" marL="0">
+            <a:pPr marL="0" indent="0">
               <a:buNone/>
             </a:pPr>
             <a:r>
@@ -3109,7 +2929,7 @@
             <a:endParaRPr lang="en-US" sz="900" dirty="0"/>
           </a:p>
           <a:p>
-            <a:pPr indent="0" marL="0">
+            <a:pPr marL="0" indent="0">
               <a:buNone/>
             </a:pPr>
             <a:r>
@@ -3126,7 +2946,7 @@
             <a:endParaRPr lang="en-US" sz="900" dirty="0"/>
           </a:p>
           <a:p>
-            <a:pPr indent="0" marL="0">
+            <a:pPr marL="0" indent="0">
               <a:buNone/>
             </a:pPr>
             <a:r>
@@ -3165,7 +2985,7 @@
           <a:bodyPr wrap="square" rtlCol="0" anchor="ctr"/>
           <a:lstStyle/>
           <a:p>
-            <a:pPr indent="0" marL="0">
+            <a:pPr marL="0" indent="0">
               <a:buNone/>
             </a:pPr>
             <a:r>
@@ -3204,6 +3024,13 @@
             <a:prstDash val="solid"/>
           </a:ln>
         </p:spPr>
+        <p:txBody>
+          <a:bodyPr/>
+          <a:lstStyle/>
+          <a:p>
+            <a:endParaRPr/>
+          </a:p>
+        </p:txBody>
       </p:sp>
       <p:sp>
         <p:nvSpPr>
@@ -3224,6 +3051,13 @@
           </a:solidFill>
           <a:ln/>
         </p:spPr>
+        <p:txBody>
+          <a:bodyPr/>
+          <a:lstStyle/>
+          <a:p>
+            <a:endParaRPr/>
+          </a:p>
+        </p:txBody>
       </p:sp>
       <p:sp>
         <p:nvSpPr>
@@ -3246,7 +3080,7 @@
           <a:bodyPr wrap="square" rtlCol="0" anchor="t"/>
           <a:lstStyle/>
           <a:p>
-            <a:pPr indent="0" marL="0">
+            <a:pPr marL="0" indent="0">
               <a:buNone/>
             </a:pPr>
             <a:r>
@@ -3263,7 +3097,7 @@
             <a:endParaRPr lang="en-US" sz="900" dirty="0"/>
           </a:p>
           <a:p>
-            <a:pPr indent="0" marL="0">
+            <a:pPr marL="0" indent="0">
               <a:buNone/>
             </a:pPr>
             <a:r>
@@ -3280,7 +3114,7 @@
             <a:endParaRPr lang="en-US" sz="900" dirty="0"/>
           </a:p>
           <a:p>
-            <a:pPr indent="0" marL="0">
+            <a:pPr marL="0" indent="0">
               <a:buNone/>
             </a:pPr>
             <a:r>
@@ -3319,7 +3153,7 @@
           <a:bodyPr wrap="square" rtlCol="0" anchor="ctr"/>
           <a:lstStyle/>
           <a:p>
-            <a:pPr indent="0" marL="0">
+            <a:pPr marL="0" indent="0">
               <a:buNone/>
             </a:pPr>
             <a:r>
@@ -3355,7 +3189,7 @@
           <a:bodyPr wrap="square" rtlCol="0" anchor="ctr"/>
           <a:lstStyle/>
           <a:p>
-            <a:pPr indent="0" marL="0">
+            <a:pPr marL="0" indent="0">
               <a:buNone/>
             </a:pPr>
             <a:r>
@@ -3391,7 +3225,7 @@
           <a:bodyPr wrap="square" rtlCol="0" anchor="ctr"/>
           <a:lstStyle/>
           <a:p>
-            <a:pPr indent="0" marL="0">
+            <a:pPr marL="0" indent="0">
               <a:buNone/>
             </a:pPr>
             <a:r>
@@ -3427,7 +3261,7 @@
           <a:bodyPr wrap="square" rtlCol="0" anchor="ctr"/>
           <a:lstStyle/>
           <a:p>
-            <a:pPr indent="0" marL="0">
+            <a:pPr marL="0" indent="0">
               <a:buNone/>
             </a:pPr>
             <a:r>
@@ -3466,6 +3300,13 @@
             <a:prstDash val="solid"/>
           </a:ln>
         </p:spPr>
+        <p:txBody>
+          <a:bodyPr/>
+          <a:lstStyle/>
+          <a:p>
+            <a:endParaRPr/>
+          </a:p>
+        </p:txBody>
       </p:sp>
       <p:sp>
         <p:nvSpPr>
@@ -3486,6 +3327,13 @@
           </a:solidFill>
           <a:ln/>
         </p:spPr>
+        <p:txBody>
+          <a:bodyPr/>
+          <a:lstStyle/>
+          <a:p>
+            <a:endParaRPr/>
+          </a:p>
+        </p:txBody>
       </p:sp>
       <p:sp>
         <p:nvSpPr>
@@ -3508,7 +3356,7 @@
           <a:bodyPr wrap="square" rtlCol="0" anchor="ctr"/>
           <a:lstStyle/>
           <a:p>
-            <a:pPr indent="0" marL="0">
+            <a:pPr marL="0" indent="0">
               <a:buNone/>
             </a:pPr>
             <a:r>
@@ -3547,7 +3395,7 @@
           <a:bodyPr wrap="square" rtlCol="0" anchor="t"/>
           <a:lstStyle/>
           <a:p>
-            <a:pPr indent="0" marL="0">
+            <a:pPr marL="0" indent="0">
               <a:buNone/>
             </a:pPr>
             <a:r>
@@ -3581,6 +3429,7 @@
         <a:solidFill>
           <a:srgbClr val="0D1117"/>
         </a:solidFill>
+        <a:effectLst/>
       </p:bgPr>
     </p:bg>
     <p:spTree>
@@ -3599,45 +3448,6 @@
       </p:grpSpPr>
       <p:sp>
         <p:nvSpPr>
-          <p:cNvPr id="2" name="Text 0"/>
-          <p:cNvSpPr/>
-          <p:nvPr/>
-        </p:nvSpPr>
-        <p:spPr>
-          <a:xfrm>
-            <a:off x="365760" y="274320"/>
-            <a:ext cx="8412480" cy="548640"/>
-          </a:xfrm>
-          <a:prstGeom prst="rect">
-            <a:avLst/>
-          </a:prstGeom>
-          <a:noFill/>
-          <a:ln/>
-        </p:spPr>
-        <p:txBody>
-          <a:bodyPr wrap="square" rtlCol="0" anchor="ctr"/>
-          <a:lstStyle/>
-          <a:p>
-            <a:pPr indent="0" marL="0">
-              <a:buNone/>
-            </a:pPr>
-            <a:r>
-              <a:rPr lang="en-US" sz="2800" b="1" dirty="0">
-                <a:solidFill>
-                  <a:srgbClr val="E6EDF3"/>
-                </a:solidFill>
-                <a:latin typeface="Arial" pitchFamily="34" charset="0"/>
-                <a:ea typeface="Arial" pitchFamily="34" charset="-122"/>
-                <a:cs typeface="Arial" pitchFamily="34" charset="-120"/>
-              </a:rPr>
-              <a:t>Session 3: Type-Safe State Machines</a:t>
-            </a:r>
-            <a:endParaRPr lang="en-US" sz="2800" dirty="0"/>
-          </a:p>
-        </p:txBody>
-      </p:sp>
-      <p:sp>
-        <p:nvSpPr>
           <p:cNvPr id="3" name="Shape 1"/>
           <p:cNvSpPr/>
           <p:nvPr/>
@@ -3655,6 +3465,13 @@
           </a:solidFill>
           <a:ln/>
         </p:spPr>
+        <p:txBody>
+          <a:bodyPr/>
+          <a:lstStyle/>
+          <a:p>
+            <a:endParaRPr/>
+          </a:p>
+        </p:txBody>
       </p:sp>
       <p:sp>
         <p:nvSpPr>
@@ -3677,7 +3494,7 @@
           <a:bodyPr wrap="square" rtlCol="0" anchor="ctr"/>
           <a:lstStyle/>
           <a:p>
-            <a:pPr algn="ctr" indent="0" marL="0">
+            <a:pPr marL="0" indent="0" algn="ctr">
               <a:buNone/>
             </a:pPr>
             <a:r>
@@ -3713,7 +3530,7 @@
           <a:bodyPr wrap="square" rtlCol="0" anchor="ctr"/>
           <a:lstStyle/>
           <a:p>
-            <a:pPr indent="0" marL="0">
+            <a:pPr marL="0" indent="0">
               <a:buNone/>
             </a:pPr>
             <a:r>
@@ -3749,7 +3566,7 @@
           <a:bodyPr wrap="square" rtlCol="0" anchor="ctr"/>
           <a:lstStyle/>
           <a:p>
-            <a:pPr indent="0" marL="0">
+            <a:pPr marL="0" indent="0">
               <a:buNone/>
             </a:pPr>
             <a:r>
@@ -3788,6 +3605,13 @@
             <a:prstDash val="solid"/>
           </a:ln>
         </p:spPr>
+        <p:txBody>
+          <a:bodyPr/>
+          <a:lstStyle/>
+          <a:p>
+            <a:endParaRPr/>
+          </a:p>
+        </p:txBody>
       </p:sp>
       <p:sp>
         <p:nvSpPr>
@@ -3808,6 +3632,13 @@
           </a:solidFill>
           <a:ln/>
         </p:spPr>
+        <p:txBody>
+          <a:bodyPr/>
+          <a:lstStyle/>
+          <a:p>
+            <a:endParaRPr/>
+          </a:p>
+        </p:txBody>
       </p:sp>
       <p:sp>
         <p:nvSpPr>
@@ -3830,7 +3661,7 @@
           <a:bodyPr wrap="square" rtlCol="0" anchor="t"/>
           <a:lstStyle/>
           <a:p>
-            <a:pPr indent="0" marL="0">
+            <a:pPr marL="0" indent="0">
               <a:buNone/>
             </a:pPr>
             <a:r>
@@ -3847,7 +3678,7 @@
             <a:endParaRPr lang="en-US" sz="900" dirty="0"/>
           </a:p>
           <a:p>
-            <a:pPr indent="0" marL="0">
+            <a:pPr marL="0" indent="0">
               <a:buNone/>
             </a:pPr>
             <a:r>
@@ -3864,7 +3695,7 @@
             <a:endParaRPr lang="en-US" sz="900" dirty="0"/>
           </a:p>
           <a:p>
-            <a:pPr indent="0" marL="0">
+            <a:pPr marL="0" indent="0">
               <a:buNone/>
             </a:pPr>
             <a:r>
@@ -3881,7 +3712,7 @@
             <a:endParaRPr lang="en-US" sz="900" dirty="0"/>
           </a:p>
           <a:p>
-            <a:pPr indent="0" marL="0">
+            <a:pPr marL="0" indent="0">
               <a:buNone/>
             </a:pPr>
             <a:r>
@@ -3898,7 +3729,7 @@
             <a:endParaRPr lang="en-US" sz="900" dirty="0"/>
           </a:p>
           <a:p>
-            <a:pPr indent="0" marL="0">
+            <a:pPr marL="0" indent="0">
               <a:buNone/>
             </a:pPr>
             <a:r>
@@ -3915,7 +3746,7 @@
             <a:endParaRPr lang="en-US" sz="900" dirty="0"/>
           </a:p>
           <a:p>
-            <a:pPr indent="0" marL="0">
+            <a:pPr marL="0" indent="0">
               <a:buNone/>
             </a:pPr>
             <a:r>
@@ -3932,7 +3763,7 @@
             <a:endParaRPr lang="en-US" sz="900" dirty="0"/>
           </a:p>
           <a:p>
-            <a:pPr indent="0" marL="0">
+            <a:pPr marL="0" indent="0">
               <a:buNone/>
             </a:pPr>
             <a:r>
@@ -3971,7 +3802,7 @@
           <a:bodyPr wrap="square" rtlCol="0" anchor="ctr"/>
           <a:lstStyle/>
           <a:p>
-            <a:pPr indent="0" marL="0">
+            <a:pPr marL="0" indent="0">
               <a:buNone/>
             </a:pPr>
             <a:r>
@@ -4010,6 +3841,13 @@
             <a:prstDash val="solid"/>
           </a:ln>
         </p:spPr>
+        <p:txBody>
+          <a:bodyPr/>
+          <a:lstStyle/>
+          <a:p>
+            <a:endParaRPr/>
+          </a:p>
+        </p:txBody>
       </p:sp>
       <p:sp>
         <p:nvSpPr>
@@ -4030,6 +3868,13 @@
           </a:solidFill>
           <a:ln/>
         </p:spPr>
+        <p:txBody>
+          <a:bodyPr/>
+          <a:lstStyle/>
+          <a:p>
+            <a:endParaRPr/>
+          </a:p>
+        </p:txBody>
       </p:sp>
       <p:sp>
         <p:nvSpPr>
@@ -4052,7 +3897,7 @@
           <a:bodyPr wrap="square" rtlCol="0" anchor="t"/>
           <a:lstStyle/>
           <a:p>
-            <a:pPr indent="0" marL="0">
+            <a:pPr marL="0" indent="0">
               <a:buNone/>
             </a:pPr>
             <a:r>
@@ -4069,7 +3914,7 @@
             <a:endParaRPr lang="en-US" sz="900" dirty="0"/>
           </a:p>
           <a:p>
-            <a:pPr indent="0" marL="0">
+            <a:pPr marL="0" indent="0">
               <a:buNone/>
             </a:pPr>
             <a:r>
@@ -4086,7 +3931,7 @@
             <a:endParaRPr lang="en-US" sz="900" dirty="0"/>
           </a:p>
           <a:p>
-            <a:pPr indent="0" marL="0">
+            <a:pPr marL="0" indent="0">
               <a:buNone/>
             </a:pPr>
             <a:r>
@@ -4103,7 +3948,7 @@
             <a:endParaRPr lang="en-US" sz="900" dirty="0"/>
           </a:p>
           <a:p>
-            <a:pPr indent="0" marL="0">
+            <a:pPr marL="0" indent="0">
               <a:buNone/>
             </a:pPr>
             <a:r>
@@ -4120,7 +3965,7 @@
             <a:endParaRPr lang="en-US" sz="900" dirty="0"/>
           </a:p>
           <a:p>
-            <a:pPr indent="0" marL="0">
+            <a:pPr marL="0" indent="0">
               <a:buNone/>
             </a:pPr>
             <a:r>
@@ -4162,6 +4007,13 @@
             <a:prstDash val="solid"/>
           </a:ln>
         </p:spPr>
+        <p:txBody>
+          <a:bodyPr/>
+          <a:lstStyle/>
+          <a:p>
+            <a:endParaRPr/>
+          </a:p>
+        </p:txBody>
       </p:sp>
       <p:sp>
         <p:nvSpPr>
@@ -4182,6 +4034,13 @@
           </a:solidFill>
           <a:ln/>
         </p:spPr>
+        <p:txBody>
+          <a:bodyPr/>
+          <a:lstStyle/>
+          <a:p>
+            <a:endParaRPr/>
+          </a:p>
+        </p:txBody>
       </p:sp>
       <p:sp>
         <p:nvSpPr>
@@ -4204,7 +4063,7 @@
           <a:bodyPr wrap="square" rtlCol="0" anchor="ctr"/>
           <a:lstStyle/>
           <a:p>
-            <a:pPr indent="0" marL="0">
+            <a:pPr marL="0" indent="0">
               <a:buNone/>
             </a:pPr>
             <a:r>
@@ -4243,7 +4102,7 @@
           <a:bodyPr wrap="square" rtlCol="0" anchor="t"/>
           <a:lstStyle/>
           <a:p>
-            <a:pPr indent="0" marL="0">
+            <a:pPr marL="0" indent="0">
               <a:buNone/>
             </a:pPr>
             <a:r>
@@ -4277,6 +4136,7 @@
         <a:solidFill>
           <a:srgbClr val="0D1117"/>
         </a:solidFill>
+        <a:effectLst/>
       </p:bgPr>
     </p:bg>
     <p:spTree>
@@ -4314,7 +4174,7 @@
           <a:bodyPr wrap="square" rtlCol="0" anchor="ctr"/>
           <a:lstStyle/>
           <a:p>
-            <a:pPr indent="0" marL="0">
+            <a:pPr marL="0" indent="0">
               <a:buNone/>
             </a:pPr>
             <a:r>
@@ -4351,6 +4211,13 @@
           </a:solidFill>
           <a:ln/>
         </p:spPr>
+        <p:txBody>
+          <a:bodyPr/>
+          <a:lstStyle/>
+          <a:p>
+            <a:endParaRPr/>
+          </a:p>
+        </p:txBody>
       </p:sp>
       <p:sp>
         <p:nvSpPr>
@@ -4371,6 +4238,13 @@
           </a:solidFill>
           <a:ln/>
         </p:spPr>
+        <p:txBody>
+          <a:bodyPr/>
+          <a:lstStyle/>
+          <a:p>
+            <a:endParaRPr/>
+          </a:p>
+        </p:txBody>
       </p:sp>
       <p:sp>
         <p:nvSpPr>
@@ -4393,7 +4267,7 @@
           <a:bodyPr wrap="square" rtlCol="0" anchor="ctr"/>
           <a:lstStyle/>
           <a:p>
-            <a:pPr indent="0" marL="0">
+            <a:pPr marL="0" indent="0">
               <a:buNone/>
             </a:pPr>
             <a:r>
@@ -4429,7 +4303,7 @@
           <a:bodyPr wrap="square" rtlCol="0" anchor="ctr"/>
           <a:lstStyle/>
           <a:p>
-            <a:pPr indent="0" marL="0">
+            <a:pPr marL="0" indent="0">
               <a:buNone/>
             </a:pPr>
             <a:r>
@@ -4465,7 +4339,7 @@
           <a:bodyPr wrap="square" rtlCol="0" anchor="ctr"/>
           <a:lstStyle/>
           <a:p>
-            <a:pPr indent="0" marL="0">
+            <a:pPr marL="0" indent="0">
               <a:buNone/>
             </a:pPr>
             <a:r>
@@ -4502,6 +4376,13 @@
           </a:solidFill>
           <a:ln/>
         </p:spPr>
+        <p:txBody>
+          <a:bodyPr/>
+          <a:lstStyle/>
+          <a:p>
+            <a:endParaRPr/>
+          </a:p>
+        </p:txBody>
       </p:sp>
       <p:sp>
         <p:nvSpPr>
@@ -4522,6 +4403,13 @@
           </a:solidFill>
           <a:ln/>
         </p:spPr>
+        <p:txBody>
+          <a:bodyPr/>
+          <a:lstStyle/>
+          <a:p>
+            <a:endParaRPr/>
+          </a:p>
+        </p:txBody>
       </p:sp>
       <p:sp>
         <p:nvSpPr>
@@ -4544,7 +4432,7 @@
           <a:bodyPr wrap="square" rtlCol="0" anchor="ctr"/>
           <a:lstStyle/>
           <a:p>
-            <a:pPr indent="0" marL="0">
+            <a:pPr marL="0" indent="0">
               <a:buNone/>
             </a:pPr>
             <a:r>
@@ -4580,7 +4468,7 @@
           <a:bodyPr wrap="square" rtlCol="0" anchor="ctr"/>
           <a:lstStyle/>
           <a:p>
-            <a:pPr indent="0" marL="0">
+            <a:pPr marL="0" indent="0">
               <a:buNone/>
             </a:pPr>
             <a:r>
@@ -4616,7 +4504,7 @@
           <a:bodyPr wrap="square" rtlCol="0" anchor="ctr"/>
           <a:lstStyle/>
           <a:p>
-            <a:pPr indent="0" marL="0">
+            <a:pPr marL="0" indent="0">
               <a:buNone/>
             </a:pPr>
             <a:r>
@@ -4653,6 +4541,13 @@
           </a:solidFill>
           <a:ln/>
         </p:spPr>
+        <p:txBody>
+          <a:bodyPr/>
+          <a:lstStyle/>
+          <a:p>
+            <a:endParaRPr/>
+          </a:p>
+        </p:txBody>
       </p:sp>
       <p:sp>
         <p:nvSpPr>
@@ -4673,6 +4568,13 @@
           </a:solidFill>
           <a:ln/>
         </p:spPr>
+        <p:txBody>
+          <a:bodyPr/>
+          <a:lstStyle/>
+          <a:p>
+            <a:endParaRPr/>
+          </a:p>
+        </p:txBody>
       </p:sp>
       <p:sp>
         <p:nvSpPr>
@@ -4695,7 +4597,7 @@
           <a:bodyPr wrap="square" rtlCol="0" anchor="ctr"/>
           <a:lstStyle/>
           <a:p>
-            <a:pPr indent="0" marL="0">
+            <a:pPr marL="0" indent="0">
               <a:buNone/>
             </a:pPr>
             <a:r>
@@ -4731,7 +4633,7 @@
           <a:bodyPr wrap="square" rtlCol="0" anchor="ctr"/>
           <a:lstStyle/>
           <a:p>
-            <a:pPr indent="0" marL="0">
+            <a:pPr marL="0" indent="0">
               <a:buNone/>
             </a:pPr>
             <a:r>
@@ -4767,7 +4669,7 @@
           <a:bodyPr wrap="square" rtlCol="0" anchor="ctr"/>
           <a:lstStyle/>
           <a:p>
-            <a:pPr indent="0" marL="0">
+            <a:pPr marL="0" indent="0">
               <a:buNone/>
             </a:pPr>
             <a:r>
@@ -4804,6 +4706,13 @@
           </a:solidFill>
           <a:ln/>
         </p:spPr>
+        <p:txBody>
+          <a:bodyPr/>
+          <a:lstStyle/>
+          <a:p>
+            <a:endParaRPr/>
+          </a:p>
+        </p:txBody>
       </p:sp>
       <p:sp>
         <p:nvSpPr>
@@ -4824,6 +4733,13 @@
           </a:solidFill>
           <a:ln/>
         </p:spPr>
+        <p:txBody>
+          <a:bodyPr/>
+          <a:lstStyle/>
+          <a:p>
+            <a:endParaRPr/>
+          </a:p>
+        </p:txBody>
       </p:sp>
       <p:sp>
         <p:nvSpPr>
@@ -4846,7 +4762,7 @@
           <a:bodyPr wrap="square" rtlCol="0" anchor="ctr"/>
           <a:lstStyle/>
           <a:p>
-            <a:pPr indent="0" marL="0">
+            <a:pPr marL="0" indent="0">
               <a:buNone/>
             </a:pPr>
             <a:r>
@@ -4882,7 +4798,7 @@
           <a:bodyPr wrap="square" rtlCol="0" anchor="ctr"/>
           <a:lstStyle/>
           <a:p>
-            <a:pPr indent="0" marL="0">
+            <a:pPr marL="0" indent="0">
               <a:buNone/>
             </a:pPr>
             <a:r>
@@ -4918,7 +4834,7 @@
           <a:bodyPr wrap="square" rtlCol="0" anchor="ctr"/>
           <a:lstStyle/>
           <a:p>
-            <a:pPr indent="0" marL="0">
+            <a:pPr marL="0" indent="0">
               <a:buNone/>
             </a:pPr>
             <a:r>
@@ -4957,18 +4873,17 @@
           <a:bodyPr wrap="square" rtlCol="0" anchor="ctr"/>
           <a:lstStyle/>
           <a:p>
-            <a:pPr algn="ctr" indent="0" marL="0">
-              <a:buNone/>
-            </a:pPr>
-            <a:r>
-              <a:rPr lang="en-US" sz="1100" b="1" dirty="0">
-                <a:solidFill>
-                  <a:srgbClr val="2A9D8F"/>
-                </a:solidFill>
-              </a:rPr>
+            <a:r>
               <a:t>All techniques share the same goal: make illegal states unrepresentable</a:t>
             </a:r>
-            <a:endParaRPr lang="en-US" sz="1100" dirty="0"/>
+          </a:p>
+          <a:p>
+            <a:endParaRPr/>
+          </a:p>
+          <a:p>
+            <a:r>
+              <a:t>Sessions 6–8 are optional extensions and are not included in this bundle.</a:t>
+            </a:r>
           </a:p>
         </p:txBody>
       </p:sp>
@@ -4988,6 +4903,7 @@
         <a:solidFill>
           <a:srgbClr val="0D1117"/>
         </a:solidFill>
+        <a:effectLst/>
       </p:bgPr>
     </p:bg>
     <p:spTree>
@@ -5025,7 +4941,7 @@
           <a:bodyPr wrap="square" rtlCol="0" anchor="ctr"/>
           <a:lstStyle/>
           <a:p>
-            <a:pPr indent="0" marL="0">
+            <a:pPr marL="0" indent="0">
               <a:buNone/>
             </a:pPr>
             <a:r>
@@ -5062,6 +4978,13 @@
           </a:solidFill>
           <a:ln/>
         </p:spPr>
+        <p:txBody>
+          <a:bodyPr/>
+          <a:lstStyle/>
+          <a:p>
+            <a:endParaRPr/>
+          </a:p>
+        </p:txBody>
       </p:sp>
       <p:sp>
         <p:nvSpPr>
@@ -5084,7 +5007,7 @@
           <a:bodyPr wrap="square" rtlCol="0" anchor="ctr"/>
           <a:lstStyle/>
           <a:p>
-            <a:pPr algn="ctr" indent="0" marL="0">
+            <a:pPr marL="0" indent="0" algn="ctr">
               <a:buNone/>
             </a:pPr>
             <a:r>
@@ -5118,6 +5041,13 @@
           </a:solidFill>
           <a:ln/>
         </p:spPr>
+        <p:txBody>
+          <a:bodyPr/>
+          <a:lstStyle/>
+          <a:p>
+            <a:endParaRPr/>
+          </a:p>
+        </p:txBody>
       </p:sp>
       <p:sp>
         <p:nvSpPr>
@@ -5140,7 +5070,7 @@
           <a:bodyPr wrap="square" rtlCol="0" anchor="ctr"/>
           <a:lstStyle/>
           <a:p>
-            <a:pPr algn="ctr" indent="0" marL="0">
+            <a:pPr marL="0" indent="0" algn="ctr">
               <a:buNone/>
             </a:pPr>
             <a:r>
@@ -5174,6 +5104,13 @@
           </a:solidFill>
           <a:ln/>
         </p:spPr>
+        <p:txBody>
+          <a:bodyPr/>
+          <a:lstStyle/>
+          <a:p>
+            <a:endParaRPr/>
+          </a:p>
+        </p:txBody>
       </p:sp>
       <p:sp>
         <p:nvSpPr>
@@ -5196,7 +5133,7 @@
           <a:bodyPr wrap="square" rtlCol="0" anchor="ctr"/>
           <a:lstStyle/>
           <a:p>
-            <a:pPr algn="ctr" indent="0" marL="0">
+            <a:pPr marL="0" indent="0" algn="ctr">
               <a:buNone/>
             </a:pPr>
             <a:r>
@@ -5230,6 +5167,13 @@
           </a:solidFill>
           <a:ln/>
         </p:spPr>
+        <p:txBody>
+          <a:bodyPr/>
+          <a:lstStyle/>
+          <a:p>
+            <a:endParaRPr/>
+          </a:p>
+        </p:txBody>
       </p:sp>
       <p:sp>
         <p:nvSpPr>
@@ -5252,7 +5196,7 @@
           <a:bodyPr wrap="square" rtlCol="0" anchor="ctr"/>
           <a:lstStyle/>
           <a:p>
-            <a:pPr algn="ctr" indent="0" marL="0">
+            <a:pPr marL="0" indent="0" algn="ctr">
               <a:buNone/>
             </a:pPr>
             <a:r>
@@ -5286,6 +5230,13 @@
           </a:solidFill>
           <a:ln/>
         </p:spPr>
+        <p:txBody>
+          <a:bodyPr/>
+          <a:lstStyle/>
+          <a:p>
+            <a:endParaRPr/>
+          </a:p>
+        </p:txBody>
       </p:sp>
       <p:sp>
         <p:nvSpPr>
@@ -5308,7 +5259,7 @@
           <a:bodyPr wrap="square" rtlCol="0" anchor="ctr"/>
           <a:lstStyle/>
           <a:p>
-            <a:pPr algn="ctr" indent="0" marL="0">
+            <a:pPr marL="0" indent="0" algn="ctr">
               <a:buNone/>
             </a:pPr>
             <a:r>
@@ -5342,6 +5293,13 @@
           </a:solidFill>
           <a:ln/>
         </p:spPr>
+        <p:txBody>
+          <a:bodyPr/>
+          <a:lstStyle/>
+          <a:p>
+            <a:endParaRPr/>
+          </a:p>
+        </p:txBody>
       </p:sp>
       <p:sp>
         <p:nvSpPr>
@@ -5364,7 +5322,7 @@
           <a:bodyPr wrap="square" rtlCol="0" anchor="ctr"/>
           <a:lstStyle/>
           <a:p>
-            <a:pPr algn="ctr" indent="0" marL="0">
+            <a:pPr marL="0" indent="0" algn="ctr">
               <a:buNone/>
             </a:pPr>
             <a:r>
@@ -5398,6 +5356,13 @@
           </a:solidFill>
           <a:ln/>
         </p:spPr>
+        <p:txBody>
+          <a:bodyPr/>
+          <a:lstStyle/>
+          <a:p>
+            <a:endParaRPr/>
+          </a:p>
+        </p:txBody>
       </p:sp>
       <p:sp>
         <p:nvSpPr>
@@ -5420,7 +5385,7 @@
           <a:bodyPr wrap="square" rtlCol="0" anchor="ctr"/>
           <a:lstStyle/>
           <a:p>
-            <a:pPr algn="ctr" indent="0" marL="0">
+            <a:pPr marL="0" indent="0" algn="ctr">
               <a:buNone/>
             </a:pPr>
             <a:r>
@@ -5454,6 +5419,13 @@
           </a:solidFill>
           <a:ln/>
         </p:spPr>
+        <p:txBody>
+          <a:bodyPr/>
+          <a:lstStyle/>
+          <a:p>
+            <a:endParaRPr/>
+          </a:p>
+        </p:txBody>
       </p:sp>
       <p:sp>
         <p:nvSpPr>
@@ -5476,7 +5448,7 @@
           <a:bodyPr wrap="square" rtlCol="0" anchor="ctr"/>
           <a:lstStyle/>
           <a:p>
-            <a:pPr algn="ctr" indent="0" marL="0">
+            <a:pPr marL="0" indent="0" algn="ctr">
               <a:buNone/>
             </a:pPr>
             <a:r>
@@ -5510,6 +5482,13 @@
           </a:solidFill>
           <a:ln/>
         </p:spPr>
+        <p:txBody>
+          <a:bodyPr/>
+          <a:lstStyle/>
+          <a:p>
+            <a:endParaRPr/>
+          </a:p>
+        </p:txBody>
       </p:sp>
       <p:sp>
         <p:nvSpPr>
@@ -5532,7 +5511,7 @@
           <a:bodyPr wrap="square" rtlCol="0" anchor="ctr"/>
           <a:lstStyle/>
           <a:p>
-            <a:pPr algn="ctr" indent="0" marL="0">
+            <a:pPr marL="0" indent="0" algn="ctr">
               <a:buNone/>
             </a:pPr>
             <a:r>
@@ -5566,6 +5545,13 @@
           </a:solidFill>
           <a:ln/>
         </p:spPr>
+        <p:txBody>
+          <a:bodyPr/>
+          <a:lstStyle/>
+          <a:p>
+            <a:endParaRPr/>
+          </a:p>
+        </p:txBody>
       </p:sp>
       <p:sp>
         <p:nvSpPr>
@@ -5588,7 +5574,7 @@
           <a:bodyPr wrap="square" rtlCol="0" anchor="ctr"/>
           <a:lstStyle/>
           <a:p>
-            <a:pPr algn="ctr" indent="0" marL="0">
+            <a:pPr marL="0" indent="0" algn="ctr">
               <a:buNone/>
             </a:pPr>
             <a:r>
@@ -5622,6 +5608,13 @@
           </a:solidFill>
           <a:ln/>
         </p:spPr>
+        <p:txBody>
+          <a:bodyPr/>
+          <a:lstStyle/>
+          <a:p>
+            <a:endParaRPr/>
+          </a:p>
+        </p:txBody>
       </p:sp>
       <p:sp>
         <p:nvSpPr>
@@ -5644,7 +5637,7 @@
           <a:bodyPr wrap="square" rtlCol="0" anchor="ctr"/>
           <a:lstStyle/>
           <a:p>
-            <a:pPr algn="ctr" indent="0" marL="0">
+            <a:pPr marL="0" indent="0" algn="ctr">
               <a:buNone/>
             </a:pPr>
             <a:r>
@@ -5678,6 +5671,13 @@
           </a:solidFill>
           <a:ln/>
         </p:spPr>
+        <p:txBody>
+          <a:bodyPr/>
+          <a:lstStyle/>
+          <a:p>
+            <a:endParaRPr/>
+          </a:p>
+        </p:txBody>
       </p:sp>
       <p:sp>
         <p:nvSpPr>
@@ -5700,7 +5700,7 @@
           <a:bodyPr wrap="square" rtlCol="0" anchor="ctr"/>
           <a:lstStyle/>
           <a:p>
-            <a:pPr algn="ctr" indent="0" marL="0">
+            <a:pPr marL="0" indent="0" algn="ctr">
               <a:buNone/>
             </a:pPr>
             <a:r>
@@ -5734,6 +5734,13 @@
           </a:solidFill>
           <a:ln/>
         </p:spPr>
+        <p:txBody>
+          <a:bodyPr/>
+          <a:lstStyle/>
+          <a:p>
+            <a:endParaRPr/>
+          </a:p>
+        </p:txBody>
       </p:sp>
       <p:sp>
         <p:nvSpPr>
@@ -5756,7 +5763,7 @@
           <a:bodyPr wrap="square" rtlCol="0" anchor="ctr"/>
           <a:lstStyle/>
           <a:p>
-            <a:pPr algn="ctr" indent="0" marL="0">
+            <a:pPr marL="0" indent="0" algn="ctr">
               <a:buNone/>
             </a:pPr>
             <a:r>
@@ -5790,6 +5797,13 @@
           </a:solidFill>
           <a:ln/>
         </p:spPr>
+        <p:txBody>
+          <a:bodyPr/>
+          <a:lstStyle/>
+          <a:p>
+            <a:endParaRPr/>
+          </a:p>
+        </p:txBody>
       </p:sp>
       <p:sp>
         <p:nvSpPr>
@@ -5812,7 +5826,7 @@
           <a:bodyPr wrap="square" rtlCol="0" anchor="ctr"/>
           <a:lstStyle/>
           <a:p>
-            <a:pPr algn="ctr" indent="0" marL="0">
+            <a:pPr marL="0" indent="0" algn="ctr">
               <a:buNone/>
             </a:pPr>
             <a:r>
@@ -5846,6 +5860,13 @@
           </a:solidFill>
           <a:ln/>
         </p:spPr>
+        <p:txBody>
+          <a:bodyPr/>
+          <a:lstStyle/>
+          <a:p>
+            <a:endParaRPr/>
+          </a:p>
+        </p:txBody>
       </p:sp>
       <p:sp>
         <p:nvSpPr>
@@ -5868,18 +5889,15 @@
           <a:bodyPr wrap="square" rtlCol="0" anchor="ctr"/>
           <a:lstStyle/>
           <a:p>
-            <a:pPr algn="ctr" indent="0" marL="0">
-              <a:buNone/>
-            </a:pPr>
-            <a:r>
-              <a:rPr lang="en-US" sz="1000" b="1" dirty="0">
-                <a:solidFill>
-                  <a:srgbClr val="2A9D8F"/>
-                </a:solidFill>
-              </a:rPr>
-              <a:t>Zero</a:t>
-            </a:r>
-            <a:endParaRPr lang="en-US" sz="1000" dirty="0"/>
+            <a:pPr algn="ctr"/>
+            <a:r>
+              <a:rPr sz="1100" dirty="0">
+                <a:solidFill>
+                  <a:schemeClr val="bg2"/>
+                </a:solidFill>
+              </a:rPr>
+              <a:t>O(1) check</a:t>
+            </a:r>
           </a:p>
         </p:txBody>
       </p:sp>
@@ -5902,6 +5920,13 @@
           </a:solidFill>
           <a:ln/>
         </p:spPr>
+        <p:txBody>
+          <a:bodyPr/>
+          <a:lstStyle/>
+          <a:p>
+            <a:endParaRPr/>
+          </a:p>
+        </p:txBody>
       </p:sp>
       <p:sp>
         <p:nvSpPr>
@@ -5924,7 +5949,7 @@
           <a:bodyPr wrap="square" rtlCol="0" anchor="ctr"/>
           <a:lstStyle/>
           <a:p>
-            <a:pPr algn="ctr" indent="0" marL="0">
+            <a:pPr marL="0" indent="0" algn="ctr">
               <a:buNone/>
             </a:pPr>
             <a:r>
@@ -5958,6 +5983,13 @@
           </a:solidFill>
           <a:ln/>
         </p:spPr>
+        <p:txBody>
+          <a:bodyPr/>
+          <a:lstStyle/>
+          <a:p>
+            <a:endParaRPr/>
+          </a:p>
+        </p:txBody>
       </p:sp>
       <p:sp>
         <p:nvSpPr>
@@ -5980,7 +6012,7 @@
           <a:bodyPr wrap="square" rtlCol="0" anchor="ctr"/>
           <a:lstStyle/>
           <a:p>
-            <a:pPr algn="ctr" indent="0" marL="0">
+            <a:pPr marL="0" indent="0" algn="ctr">
               <a:buNone/>
             </a:pPr>
             <a:r>
@@ -6014,6 +6046,13 @@
           </a:solidFill>
           <a:ln/>
         </p:spPr>
+        <p:txBody>
+          <a:bodyPr/>
+          <a:lstStyle/>
+          <a:p>
+            <a:endParaRPr/>
+          </a:p>
+        </p:txBody>
       </p:sp>
       <p:sp>
         <p:nvSpPr>
@@ -6036,7 +6075,7 @@
           <a:bodyPr wrap="square" rtlCol="0" anchor="ctr"/>
           <a:lstStyle/>
           <a:p>
-            <a:pPr algn="ctr" indent="0" marL="0">
+            <a:pPr marL="0" indent="0" algn="ctr">
               <a:buNone/>
             </a:pPr>
             <a:r>
@@ -6070,6 +6109,13 @@
           </a:solidFill>
           <a:ln/>
         </p:spPr>
+        <p:txBody>
+          <a:bodyPr/>
+          <a:lstStyle/>
+          <a:p>
+            <a:endParaRPr/>
+          </a:p>
+        </p:txBody>
       </p:sp>
       <p:sp>
         <p:nvSpPr>
@@ -6092,7 +6138,7 @@
           <a:bodyPr wrap="square" rtlCol="0" anchor="ctr"/>
           <a:lstStyle/>
           <a:p>
-            <a:pPr algn="ctr" indent="0" marL="0">
+            <a:pPr marL="0" indent="0" algn="ctr">
               <a:buNone/>
             </a:pPr>
             <a:r>
@@ -6126,6 +6172,13 @@
           </a:solidFill>
           <a:ln/>
         </p:spPr>
+        <p:txBody>
+          <a:bodyPr/>
+          <a:lstStyle/>
+          <a:p>
+            <a:endParaRPr/>
+          </a:p>
+        </p:txBody>
       </p:sp>
       <p:sp>
         <p:nvSpPr>
@@ -6148,7 +6201,7 @@
           <a:bodyPr wrap="square" rtlCol="0" anchor="ctr"/>
           <a:lstStyle/>
           <a:p>
-            <a:pPr algn="ctr" indent="0" marL="0">
+            <a:pPr marL="0" indent="0" algn="ctr">
               <a:buNone/>
             </a:pPr>
             <a:r>
@@ -6182,6 +6235,13 @@
           </a:solidFill>
           <a:ln/>
         </p:spPr>
+        <p:txBody>
+          <a:bodyPr/>
+          <a:lstStyle/>
+          <a:p>
+            <a:endParaRPr/>
+          </a:p>
+        </p:txBody>
       </p:sp>
       <p:sp>
         <p:nvSpPr>
@@ -6204,7 +6264,7 @@
           <a:bodyPr wrap="square" rtlCol="0" anchor="ctr"/>
           <a:lstStyle/>
           <a:p>
-            <a:pPr algn="ctr" indent="0" marL="0">
+            <a:pPr marL="0" indent="0" algn="ctr">
               <a:buNone/>
             </a:pPr>
             <a:r>
@@ -6238,6 +6298,13 @@
           </a:solidFill>
           <a:ln/>
         </p:spPr>
+        <p:txBody>
+          <a:bodyPr/>
+          <a:lstStyle/>
+          <a:p>
+            <a:endParaRPr/>
+          </a:p>
+        </p:txBody>
       </p:sp>
       <p:sp>
         <p:nvSpPr>
@@ -6260,7 +6327,7 @@
           <a:bodyPr wrap="square" rtlCol="0" anchor="ctr"/>
           <a:lstStyle/>
           <a:p>
-            <a:pPr algn="ctr" indent="0" marL="0">
+            <a:pPr marL="0" indent="0" algn="ctr">
               <a:buNone/>
             </a:pPr>
             <a:r>
@@ -6294,6 +6361,13 @@
           </a:solidFill>
           <a:ln/>
         </p:spPr>
+        <p:txBody>
+          <a:bodyPr/>
+          <a:lstStyle/>
+          <a:p>
+            <a:endParaRPr/>
+          </a:p>
+        </p:txBody>
       </p:sp>
       <p:sp>
         <p:nvSpPr>
@@ -6316,7 +6390,7 @@
           <a:bodyPr wrap="square" rtlCol="0" anchor="ctr"/>
           <a:lstStyle/>
           <a:p>
-            <a:pPr algn="ctr" indent="0" marL="0">
+            <a:pPr marL="0" indent="0" algn="ctr">
               <a:buNone/>
             </a:pPr>
             <a:r>
@@ -6350,6 +6424,13 @@
           </a:solidFill>
           <a:ln/>
         </p:spPr>
+        <p:txBody>
+          <a:bodyPr/>
+          <a:lstStyle/>
+          <a:p>
+            <a:endParaRPr/>
+          </a:p>
+        </p:txBody>
       </p:sp>
       <p:sp>
         <p:nvSpPr>
@@ -6372,7 +6453,7 @@
           <a:bodyPr wrap="square" rtlCol="0" anchor="ctr"/>
           <a:lstStyle/>
           <a:p>
-            <a:pPr algn="ctr" indent="0" marL="0">
+            <a:pPr marL="0" indent="0" algn="ctr">
               <a:buNone/>
             </a:pPr>
             <a:r>
@@ -6395,31 +6476,27 @@
         </p:nvSpPr>
         <p:spPr>
           <a:xfrm>
-            <a:off x="365760" y="4206240"/>
-            <a:ext cx="8412480" cy="274320"/>
-          </a:xfrm>
-          <a:prstGeom prst="rect">
-            <a:avLst/>
-          </a:prstGeom>
-          <a:noFill/>
-          <a:ln/>
-        </p:spPr>
-        <p:txBody>
-          <a:bodyPr wrap="square" rtlCol="0" anchor="ctr"/>
-          <a:lstStyle/>
-          <a:p>
-            <a:pPr algn="ctr" indent="0" marL="0">
-              <a:buNone/>
-            </a:pPr>
-            <a:r>
-              <a:rPr lang="en-US" sz="1100" b="1" dirty="0">
-                <a:solidFill>
-                  <a:srgbClr val="2A9D8F"/>
-                </a:solidFill>
-              </a:rPr>
-              <a:t>Every technique has zero runtime cost for the safety it provides</a:t>
-            </a:r>
-            <a:endParaRPr lang="en-US" sz="1100" dirty="0"/>
+            <a:off x="365760" y="3931920"/>
+            <a:ext cx="8412480" cy="548640"/>
+          </a:xfrm>
+          <a:prstGeom prst="rect">
+            <a:avLst/>
+          </a:prstGeom>
+          <a:noFill/>
+          <a:ln/>
+        </p:spPr>
+        <p:txBody>
+          <a:bodyPr wrap="square" rtlCol="0" anchor="ctr"/>
+          <a:lstStyle/>
+          <a:p>
+            <a:r>
+              <a:rPr dirty="0">
+                <a:solidFill>
+                  <a:schemeClr val="bg2"/>
+                </a:solidFill>
+              </a:rPr>
+              <a:t>Most techniques have zero runtime cost; when there is runtime work (e.g., StateMachine), it is explicit and O(1).</a:t>
+            </a:r>
           </a:p>
         </p:txBody>
       </p:sp>
@@ -6439,6 +6516,7 @@
         <a:solidFill>
           <a:srgbClr val="0D1117"/>
         </a:solidFill>
+        <a:effectLst/>
       </p:bgPr>
     </p:bg>
     <p:spTree>
@@ -6476,7 +6554,7 @@
           <a:bodyPr wrap="square" rtlCol="0" anchor="ctr"/>
           <a:lstStyle/>
           <a:p>
-            <a:pPr indent="0" marL="0">
+            <a:pPr marL="0" indent="0">
               <a:buNone/>
             </a:pPr>
             <a:r>
@@ -6513,6 +6591,13 @@
           </a:solidFill>
           <a:ln/>
         </p:spPr>
+        <p:txBody>
+          <a:bodyPr/>
+          <a:lstStyle/>
+          <a:p>
+            <a:endParaRPr/>
+          </a:p>
+        </p:txBody>
       </p:sp>
       <p:sp>
         <p:nvSpPr>
@@ -6533,6 +6618,13 @@
           </a:solidFill>
           <a:ln/>
         </p:spPr>
+        <p:txBody>
+          <a:bodyPr/>
+          <a:lstStyle/>
+          <a:p>
+            <a:endParaRPr/>
+          </a:p>
+        </p:txBody>
       </p:sp>
       <p:sp>
         <p:nvSpPr>
@@ -6553,6 +6645,13 @@
           </a:solidFill>
           <a:ln/>
         </p:spPr>
+        <p:txBody>
+          <a:bodyPr/>
+          <a:lstStyle/>
+          <a:p>
+            <a:endParaRPr/>
+          </a:p>
+        </p:txBody>
       </p:sp>
       <p:sp>
         <p:nvSpPr>
@@ -6575,7 +6674,7 @@
           <a:bodyPr wrap="square" rtlCol="0" anchor="ctr"/>
           <a:lstStyle/>
           <a:p>
-            <a:pPr algn="ctr" indent="0" marL="0">
+            <a:pPr marL="0" indent="0" algn="ctr">
               <a:buNone/>
             </a:pPr>
             <a:r>
@@ -6611,7 +6710,7 @@
           <a:bodyPr wrap="square" rtlCol="0" anchor="ctr"/>
           <a:lstStyle/>
           <a:p>
-            <a:pPr indent="0" marL="0">
+            <a:pPr marL="0" indent="0">
               <a:buNone/>
             </a:pPr>
             <a:r>
@@ -6647,7 +6746,7 @@
           <a:bodyPr wrap="square" rtlCol="0" anchor="ctr"/>
           <a:lstStyle/>
           <a:p>
-            <a:pPr indent="0" marL="0">
+            <a:pPr marL="0" indent="0">
               <a:buNone/>
             </a:pPr>
             <a:r>
@@ -6684,6 +6783,13 @@
           </a:solidFill>
           <a:ln/>
         </p:spPr>
+        <p:txBody>
+          <a:bodyPr/>
+          <a:lstStyle/>
+          <a:p>
+            <a:endParaRPr/>
+          </a:p>
+        </p:txBody>
       </p:sp>
       <p:sp>
         <p:nvSpPr>
@@ -6704,6 +6810,13 @@
           </a:solidFill>
           <a:ln/>
         </p:spPr>
+        <p:txBody>
+          <a:bodyPr/>
+          <a:lstStyle/>
+          <a:p>
+            <a:endParaRPr/>
+          </a:p>
+        </p:txBody>
       </p:sp>
       <p:sp>
         <p:nvSpPr>
@@ -6724,6 +6837,13 @@
           </a:solidFill>
           <a:ln/>
         </p:spPr>
+        <p:txBody>
+          <a:bodyPr/>
+          <a:lstStyle/>
+          <a:p>
+            <a:endParaRPr/>
+          </a:p>
+        </p:txBody>
       </p:sp>
       <p:sp>
         <p:nvSpPr>
@@ -6746,7 +6866,7 @@
           <a:bodyPr wrap="square" rtlCol="0" anchor="ctr"/>
           <a:lstStyle/>
           <a:p>
-            <a:pPr algn="ctr" indent="0" marL="0">
+            <a:pPr marL="0" indent="0" algn="ctr">
               <a:buNone/>
             </a:pPr>
             <a:r>
@@ -6782,7 +6902,7 @@
           <a:bodyPr wrap="square" rtlCol="0" anchor="ctr"/>
           <a:lstStyle/>
           <a:p>
-            <a:pPr indent="0" marL="0">
+            <a:pPr marL="0" indent="0">
               <a:buNone/>
             </a:pPr>
             <a:r>
@@ -6818,7 +6938,7 @@
           <a:bodyPr wrap="square" rtlCol="0" anchor="ctr"/>
           <a:lstStyle/>
           <a:p>
-            <a:pPr indent="0" marL="0">
+            <a:pPr marL="0" indent="0">
               <a:buNone/>
             </a:pPr>
             <a:r>
@@ -6855,6 +6975,13 @@
           </a:solidFill>
           <a:ln/>
         </p:spPr>
+        <p:txBody>
+          <a:bodyPr/>
+          <a:lstStyle/>
+          <a:p>
+            <a:endParaRPr/>
+          </a:p>
+        </p:txBody>
       </p:sp>
       <p:sp>
         <p:nvSpPr>
@@ -6875,6 +7002,13 @@
           </a:solidFill>
           <a:ln/>
         </p:spPr>
+        <p:txBody>
+          <a:bodyPr/>
+          <a:lstStyle/>
+          <a:p>
+            <a:endParaRPr/>
+          </a:p>
+        </p:txBody>
       </p:sp>
       <p:sp>
         <p:nvSpPr>
@@ -6895,6 +7029,13 @@
           </a:solidFill>
           <a:ln/>
         </p:spPr>
+        <p:txBody>
+          <a:bodyPr/>
+          <a:lstStyle/>
+          <a:p>
+            <a:endParaRPr/>
+          </a:p>
+        </p:txBody>
       </p:sp>
       <p:sp>
         <p:nvSpPr>
@@ -6917,7 +7058,7 @@
           <a:bodyPr wrap="square" rtlCol="0" anchor="ctr"/>
           <a:lstStyle/>
           <a:p>
-            <a:pPr algn="ctr" indent="0" marL="0">
+            <a:pPr marL="0" indent="0" algn="ctr">
               <a:buNone/>
             </a:pPr>
             <a:r>
@@ -6953,7 +7094,7 @@
           <a:bodyPr wrap="square" rtlCol="0" anchor="ctr"/>
           <a:lstStyle/>
           <a:p>
-            <a:pPr indent="0" marL="0">
+            <a:pPr marL="0" indent="0">
               <a:buNone/>
             </a:pPr>
             <a:r>
@@ -6989,7 +7130,7 @@
           <a:bodyPr wrap="square" rtlCol="0" anchor="ctr"/>
           <a:lstStyle/>
           <a:p>
-            <a:pPr indent="0" marL="0">
+            <a:pPr marL="0" indent="0">
               <a:buNone/>
             </a:pPr>
             <a:r>
@@ -7026,6 +7167,13 @@
           </a:solidFill>
           <a:ln/>
         </p:spPr>
+        <p:txBody>
+          <a:bodyPr/>
+          <a:lstStyle/>
+          <a:p>
+            <a:endParaRPr/>
+          </a:p>
+        </p:txBody>
       </p:sp>
       <p:sp>
         <p:nvSpPr>
@@ -7046,6 +7194,13 @@
           </a:solidFill>
           <a:ln/>
         </p:spPr>
+        <p:txBody>
+          <a:bodyPr/>
+          <a:lstStyle/>
+          <a:p>
+            <a:endParaRPr/>
+          </a:p>
+        </p:txBody>
       </p:sp>
       <p:sp>
         <p:nvSpPr>
@@ -7066,6 +7221,13 @@
           </a:solidFill>
           <a:ln/>
         </p:spPr>
+        <p:txBody>
+          <a:bodyPr/>
+          <a:lstStyle/>
+          <a:p>
+            <a:endParaRPr/>
+          </a:p>
+        </p:txBody>
       </p:sp>
       <p:sp>
         <p:nvSpPr>
@@ -7088,7 +7250,7 @@
           <a:bodyPr wrap="square" rtlCol="0" anchor="ctr"/>
           <a:lstStyle/>
           <a:p>
-            <a:pPr algn="ctr" indent="0" marL="0">
+            <a:pPr marL="0" indent="0" algn="ctr">
               <a:buNone/>
             </a:pPr>
             <a:r>
@@ -7124,7 +7286,7 @@
           <a:bodyPr wrap="square" rtlCol="0" anchor="ctr"/>
           <a:lstStyle/>
           <a:p>
-            <a:pPr indent="0" marL="0">
+            <a:pPr marL="0" indent="0">
               <a:buNone/>
             </a:pPr>
             <a:r>
@@ -7160,7 +7322,7 @@
           <a:bodyPr wrap="square" rtlCol="0" anchor="ctr"/>
           <a:lstStyle/>
           <a:p>
-            <a:pPr indent="0" marL="0">
+            <a:pPr marL="0" indent="0">
               <a:buNone/>
             </a:pPr>
             <a:r>
@@ -7197,6 +7359,13 @@
           </a:solidFill>
           <a:ln/>
         </p:spPr>
+        <p:txBody>
+          <a:bodyPr/>
+          <a:lstStyle/>
+          <a:p>
+            <a:endParaRPr/>
+          </a:p>
+        </p:txBody>
       </p:sp>
       <p:sp>
         <p:nvSpPr>
@@ -7217,6 +7386,13 @@
           </a:solidFill>
           <a:ln/>
         </p:spPr>
+        <p:txBody>
+          <a:bodyPr/>
+          <a:lstStyle/>
+          <a:p>
+            <a:endParaRPr/>
+          </a:p>
+        </p:txBody>
       </p:sp>
       <p:sp>
         <p:nvSpPr>
@@ -7237,6 +7413,13 @@
           </a:solidFill>
           <a:ln/>
         </p:spPr>
+        <p:txBody>
+          <a:bodyPr/>
+          <a:lstStyle/>
+          <a:p>
+            <a:endParaRPr/>
+          </a:p>
+        </p:txBody>
       </p:sp>
       <p:sp>
         <p:nvSpPr>
@@ -7259,7 +7442,7 @@
           <a:bodyPr wrap="square" rtlCol="0" anchor="ctr"/>
           <a:lstStyle/>
           <a:p>
-            <a:pPr algn="ctr" indent="0" marL="0">
+            <a:pPr marL="0" indent="0" algn="ctr">
               <a:buNone/>
             </a:pPr>
             <a:r>
@@ -7295,7 +7478,7 @@
           <a:bodyPr wrap="square" rtlCol="0" anchor="ctr"/>
           <a:lstStyle/>
           <a:p>
-            <a:pPr indent="0" marL="0">
+            <a:pPr marL="0" indent="0">
               <a:buNone/>
             </a:pPr>
             <a:r>
@@ -7331,7 +7514,7 @@
           <a:bodyPr wrap="square" rtlCol="0" anchor="ctr"/>
           <a:lstStyle/>
           <a:p>
-            <a:pPr indent="0" marL="0">
+            <a:pPr marL="0" indent="0">
               <a:buNone/>
             </a:pPr>
             <a:r>
@@ -7368,6 +7551,13 @@
           </a:solidFill>
           <a:ln/>
         </p:spPr>
+        <p:txBody>
+          <a:bodyPr/>
+          <a:lstStyle/>
+          <a:p>
+            <a:endParaRPr/>
+          </a:p>
+        </p:txBody>
       </p:sp>
       <p:sp>
         <p:nvSpPr>
@@ -7388,6 +7578,13 @@
           </a:solidFill>
           <a:ln/>
         </p:spPr>
+        <p:txBody>
+          <a:bodyPr/>
+          <a:lstStyle/>
+          <a:p>
+            <a:endParaRPr/>
+          </a:p>
+        </p:txBody>
       </p:sp>
       <p:sp>
         <p:nvSpPr>
@@ -7408,6 +7605,13 @@
           </a:solidFill>
           <a:ln/>
         </p:spPr>
+        <p:txBody>
+          <a:bodyPr/>
+          <a:lstStyle/>
+          <a:p>
+            <a:endParaRPr/>
+          </a:p>
+        </p:txBody>
       </p:sp>
       <p:sp>
         <p:nvSpPr>
@@ -7430,7 +7634,7 @@
           <a:bodyPr wrap="square" rtlCol="0" anchor="ctr"/>
           <a:lstStyle/>
           <a:p>
-            <a:pPr algn="ctr" indent="0" marL="0">
+            <a:pPr marL="0" indent="0" algn="ctr">
               <a:buNone/>
             </a:pPr>
             <a:r>
@@ -7466,18 +7670,9 @@
           <a:bodyPr wrap="square" rtlCol="0" anchor="ctr"/>
           <a:lstStyle/>
           <a:p>
-            <a:pPr indent="0" marL="0">
-              <a:buNone/>
-            </a:pPr>
-            <a:r>
-              <a:rPr lang="en-US" sz="1100" b="1" dirty="0">
-                <a:solidFill>
-                  <a:srgbClr val="E6EDF3"/>
-                </a:solidFill>
-              </a:rPr>
-              <a:t>Non-Null References</a:t>
-            </a:r>
-            <a:endParaRPr lang="en-US" sz="1100" dirty="0"/>
+            <a:r>
+              <a:t>Non-Null References (optional)</a:t>
+            </a:r>
           </a:p>
         </p:txBody>
       </p:sp>
@@ -7502,7 +7697,349 @@
           <a:bodyPr wrap="square" rtlCol="0" anchor="ctr"/>
           <a:lstStyle/>
           <a:p>
-            <a:pPr indent="0" marL="0">
+            <a:r>
+              <a:t>—</a:t>
+            </a:r>
+          </a:p>
+        </p:txBody>
+      </p:sp>
+      <p:sp>
+        <p:nvSpPr>
+          <p:cNvPr id="39" name="Shape 37"/>
+          <p:cNvSpPr/>
+          <p:nvPr/>
+        </p:nvSpPr>
+        <p:spPr>
+          <a:xfrm>
+            <a:off x="4754880" y="2286000"/>
+            <a:ext cx="4206240" cy="502920"/>
+          </a:xfrm>
+          <a:prstGeom prst="rect">
+            <a:avLst/>
+          </a:prstGeom>
+          <a:solidFill>
+            <a:srgbClr val="161B22"/>
+          </a:solidFill>
+          <a:ln/>
+        </p:spPr>
+        <p:txBody>
+          <a:bodyPr/>
+          <a:lstStyle/>
+          <a:p>
+            <a:endParaRPr/>
+          </a:p>
+        </p:txBody>
+      </p:sp>
+      <p:sp>
+        <p:nvSpPr>
+          <p:cNvPr id="40" name="Shape 38"/>
+          <p:cNvSpPr/>
+          <p:nvPr/>
+        </p:nvSpPr>
+        <p:spPr>
+          <a:xfrm>
+            <a:off x="4754880" y="2286000"/>
+            <a:ext cx="27432" cy="502920"/>
+          </a:xfrm>
+          <a:prstGeom prst="rect">
+            <a:avLst/>
+          </a:prstGeom>
+          <a:solidFill>
+            <a:srgbClr val="8B949E"/>
+          </a:solidFill>
+          <a:ln/>
+        </p:spPr>
+        <p:txBody>
+          <a:bodyPr/>
+          <a:lstStyle/>
+          <a:p>
+            <a:endParaRPr/>
+          </a:p>
+        </p:txBody>
+      </p:sp>
+      <p:sp>
+        <p:nvSpPr>
+          <p:cNvPr id="41" name="Shape 39"/>
+          <p:cNvSpPr/>
+          <p:nvPr/>
+        </p:nvSpPr>
+        <p:spPr>
+          <a:xfrm>
+            <a:off x="4846320" y="2395728"/>
+            <a:ext cx="320040" cy="274320"/>
+          </a:xfrm>
+          <a:prstGeom prst="rect">
+            <a:avLst/>
+          </a:prstGeom>
+          <a:solidFill>
+            <a:srgbClr val="8B949E"/>
+          </a:solidFill>
+          <a:ln/>
+        </p:spPr>
+        <p:txBody>
+          <a:bodyPr/>
+          <a:lstStyle/>
+          <a:p>
+            <a:endParaRPr/>
+          </a:p>
+        </p:txBody>
+      </p:sp>
+      <p:sp>
+        <p:nvSpPr>
+          <p:cNvPr id="42" name="Text 40"/>
+          <p:cNvSpPr/>
+          <p:nvPr/>
+        </p:nvSpPr>
+        <p:spPr>
+          <a:xfrm>
+            <a:off x="4846320" y="2395728"/>
+            <a:ext cx="320040" cy="274320"/>
+          </a:xfrm>
+          <a:prstGeom prst="rect">
+            <a:avLst/>
+          </a:prstGeom>
+          <a:noFill/>
+          <a:ln/>
+        </p:spPr>
+        <p:txBody>
+          <a:bodyPr wrap="square" rtlCol="0" anchor="ctr"/>
+          <a:lstStyle/>
+          <a:p>
+            <a:pPr marL="0" indent="0" algn="ctr">
+              <a:buNone/>
+            </a:pPr>
+            <a:r>
+              <a:rPr lang="en-US" sz="1000" b="1" dirty="0">
+                <a:solidFill>
+                  <a:srgbClr val="FFFFFF"/>
+                </a:solidFill>
+              </a:rPr>
+              <a:t>7</a:t>
+            </a:r>
+            <a:endParaRPr lang="en-US" sz="1000" dirty="0"/>
+          </a:p>
+        </p:txBody>
+      </p:sp>
+      <p:sp>
+        <p:nvSpPr>
+          <p:cNvPr id="43" name="Text 41"/>
+          <p:cNvSpPr/>
+          <p:nvPr/>
+        </p:nvSpPr>
+        <p:spPr>
+          <a:xfrm>
+            <a:off x="5257800" y="2359152"/>
+            <a:ext cx="3474720" cy="228600"/>
+          </a:xfrm>
+          <a:prstGeom prst="rect">
+            <a:avLst/>
+          </a:prstGeom>
+          <a:noFill/>
+          <a:ln/>
+        </p:spPr>
+        <p:txBody>
+          <a:bodyPr wrap="square" rtlCol="0" anchor="ctr"/>
+          <a:lstStyle/>
+          <a:p>
+            <a:r>
+              <a:t>[[nodiscard]] (optional)</a:t>
+            </a:r>
+          </a:p>
+        </p:txBody>
+      </p:sp>
+      <p:sp>
+        <p:nvSpPr>
+          <p:cNvPr id="44" name="Text 42"/>
+          <p:cNvSpPr/>
+          <p:nvPr/>
+        </p:nvSpPr>
+        <p:spPr>
+          <a:xfrm>
+            <a:off x="5257800" y="2560320"/>
+            <a:ext cx="3474720" cy="182880"/>
+          </a:xfrm>
+          <a:prstGeom prst="rect">
+            <a:avLst/>
+          </a:prstGeom>
+          <a:noFill/>
+          <a:ln/>
+        </p:spPr>
+        <p:txBody>
+          <a:bodyPr wrap="square" rtlCol="0" anchor="ctr"/>
+          <a:lstStyle/>
+          <a:p>
+            <a:r>
+              <a:t>Expected / std::expected</a:t>
+            </a:r>
+          </a:p>
+        </p:txBody>
+      </p:sp>
+      <p:sp>
+        <p:nvSpPr>
+          <p:cNvPr id="45" name="Shape 43"/>
+          <p:cNvSpPr/>
+          <p:nvPr/>
+        </p:nvSpPr>
+        <p:spPr>
+          <a:xfrm>
+            <a:off x="4754880" y="2971800"/>
+            <a:ext cx="4206240" cy="502920"/>
+          </a:xfrm>
+          <a:prstGeom prst="rect">
+            <a:avLst/>
+          </a:prstGeom>
+          <a:solidFill>
+            <a:srgbClr val="161B22"/>
+          </a:solidFill>
+          <a:ln/>
+        </p:spPr>
+        <p:txBody>
+          <a:bodyPr/>
+          <a:lstStyle/>
+          <a:p>
+            <a:endParaRPr/>
+          </a:p>
+        </p:txBody>
+      </p:sp>
+      <p:sp>
+        <p:nvSpPr>
+          <p:cNvPr id="46" name="Shape 44"/>
+          <p:cNvSpPr/>
+          <p:nvPr/>
+        </p:nvSpPr>
+        <p:spPr>
+          <a:xfrm>
+            <a:off x="4754880" y="2971800"/>
+            <a:ext cx="27432" cy="502920"/>
+          </a:xfrm>
+          <a:prstGeom prst="rect">
+            <a:avLst/>
+          </a:prstGeom>
+          <a:solidFill>
+            <a:srgbClr val="8B949E"/>
+          </a:solidFill>
+          <a:ln/>
+        </p:spPr>
+        <p:txBody>
+          <a:bodyPr/>
+          <a:lstStyle/>
+          <a:p>
+            <a:endParaRPr/>
+          </a:p>
+        </p:txBody>
+      </p:sp>
+      <p:sp>
+        <p:nvSpPr>
+          <p:cNvPr id="47" name="Shape 45"/>
+          <p:cNvSpPr/>
+          <p:nvPr/>
+        </p:nvSpPr>
+        <p:spPr>
+          <a:xfrm>
+            <a:off x="4846320" y="3081528"/>
+            <a:ext cx="320040" cy="274320"/>
+          </a:xfrm>
+          <a:prstGeom prst="rect">
+            <a:avLst/>
+          </a:prstGeom>
+          <a:solidFill>
+            <a:srgbClr val="8B949E"/>
+          </a:solidFill>
+          <a:ln/>
+        </p:spPr>
+        <p:txBody>
+          <a:bodyPr/>
+          <a:lstStyle/>
+          <a:p>
+            <a:endParaRPr/>
+          </a:p>
+        </p:txBody>
+      </p:sp>
+      <p:sp>
+        <p:nvSpPr>
+          <p:cNvPr id="48" name="Text 46"/>
+          <p:cNvSpPr/>
+          <p:nvPr/>
+        </p:nvSpPr>
+        <p:spPr>
+          <a:xfrm>
+            <a:off x="4846320" y="3081528"/>
+            <a:ext cx="320040" cy="274320"/>
+          </a:xfrm>
+          <a:prstGeom prst="rect">
+            <a:avLst/>
+          </a:prstGeom>
+          <a:noFill/>
+          <a:ln/>
+        </p:spPr>
+        <p:txBody>
+          <a:bodyPr wrap="square" rtlCol="0" anchor="ctr"/>
+          <a:lstStyle/>
+          <a:p>
+            <a:pPr marL="0" indent="0" algn="ctr">
+              <a:buNone/>
+            </a:pPr>
+            <a:r>
+              <a:rPr lang="en-US" sz="1000" b="1" dirty="0">
+                <a:solidFill>
+                  <a:srgbClr val="FFFFFF"/>
+                </a:solidFill>
+              </a:rPr>
+              <a:t>8</a:t>
+            </a:r>
+            <a:endParaRPr lang="en-US" sz="1000" dirty="0"/>
+          </a:p>
+        </p:txBody>
+      </p:sp>
+      <p:sp>
+        <p:nvSpPr>
+          <p:cNvPr id="49" name="Text 47"/>
+          <p:cNvSpPr/>
+          <p:nvPr/>
+        </p:nvSpPr>
+        <p:spPr>
+          <a:xfrm>
+            <a:off x="5257800" y="3044952"/>
+            <a:ext cx="3474720" cy="228600"/>
+          </a:xfrm>
+          <a:prstGeom prst="rect">
+            <a:avLst/>
+          </a:prstGeom>
+          <a:noFill/>
+          <a:ln/>
+        </p:spPr>
+        <p:txBody>
+          <a:bodyPr wrap="square" rtlCol="0" anchor="ctr"/>
+          <a:lstStyle/>
+          <a:p>
+            <a:r>
+              <a:t>Template Constraints (optional)</a:t>
+            </a:r>
+          </a:p>
+        </p:txBody>
+      </p:sp>
+      <p:sp>
+        <p:nvSpPr>
+          <p:cNvPr id="50" name="Text 48"/>
+          <p:cNvSpPr/>
+          <p:nvPr/>
+        </p:nvSpPr>
+        <p:spPr>
+          <a:xfrm>
+            <a:off x="5257800" y="3246120"/>
+            <a:ext cx="3474720" cy="182880"/>
+          </a:xfrm>
+          <a:prstGeom prst="rect">
+            <a:avLst/>
+          </a:prstGeom>
+          <a:noFill/>
+          <a:ln/>
+        </p:spPr>
+        <p:txBody>
+          <a:bodyPr wrap="square" rtlCol="0" anchor="ctr"/>
+          <a:lstStyle/>
+          <a:p>
+            <a:pPr marL="0" indent="0">
               <a:buNone/>
             </a:pPr>
             <a:r>
@@ -7514,7 +8051,7 @@
                 <a:ea typeface="Courier New" pitchFamily="34" charset="-122"/>
                 <a:cs typeface="Courier New" pitchFamily="34" charset="-120"/>
               </a:rPr>
-              <a:t>Expected</a:t>
+              <a:t>SFINAE / Concepts</a:t>
             </a:r>
             <a:endParaRPr lang="en-US" sz="800" dirty="0"/>
           </a:p>
@@ -7522,343 +8059,32 @@
       </p:sp>
       <p:sp>
         <p:nvSpPr>
-          <p:cNvPr id="39" name="Shape 37"/>
-          <p:cNvSpPr/>
-          <p:nvPr/>
-        </p:nvSpPr>
-        <p:spPr>
-          <a:xfrm>
-            <a:off x="4754880" y="2286000"/>
-            <a:ext cx="4206240" cy="502920"/>
-          </a:xfrm>
-          <a:prstGeom prst="rect">
-            <a:avLst/>
-          </a:prstGeom>
-          <a:solidFill>
-            <a:srgbClr val="161B22"/>
-          </a:solidFill>
-          <a:ln/>
-        </p:spPr>
-      </p:sp>
-      <p:sp>
-        <p:nvSpPr>
-          <p:cNvPr id="40" name="Shape 38"/>
-          <p:cNvSpPr/>
-          <p:nvPr/>
-        </p:nvSpPr>
-        <p:spPr>
-          <a:xfrm>
-            <a:off x="4754880" y="2286000"/>
-            <a:ext cx="27432" cy="502920"/>
-          </a:xfrm>
-          <a:prstGeom prst="rect">
-            <a:avLst/>
-          </a:prstGeom>
-          <a:solidFill>
-            <a:srgbClr val="8B949E"/>
-          </a:solidFill>
-          <a:ln/>
-        </p:spPr>
-      </p:sp>
-      <p:sp>
-        <p:nvSpPr>
-          <p:cNvPr id="41" name="Shape 39"/>
-          <p:cNvSpPr/>
-          <p:nvPr/>
-        </p:nvSpPr>
-        <p:spPr>
-          <a:xfrm>
-            <a:off x="4846320" y="2395728"/>
-            <a:ext cx="320040" cy="274320"/>
-          </a:xfrm>
-          <a:prstGeom prst="rect">
-            <a:avLst/>
-          </a:prstGeom>
-          <a:solidFill>
-            <a:srgbClr val="8B949E"/>
-          </a:solidFill>
-          <a:ln/>
-        </p:spPr>
-      </p:sp>
-      <p:sp>
-        <p:nvSpPr>
-          <p:cNvPr id="42" name="Text 40"/>
-          <p:cNvSpPr/>
-          <p:nvPr/>
-        </p:nvSpPr>
-        <p:spPr>
-          <a:xfrm>
-            <a:off x="4846320" y="2395728"/>
-            <a:ext cx="320040" cy="274320"/>
-          </a:xfrm>
-          <a:prstGeom prst="rect">
-            <a:avLst/>
-          </a:prstGeom>
-          <a:noFill/>
-          <a:ln/>
-        </p:spPr>
-        <p:txBody>
-          <a:bodyPr wrap="square" rtlCol="0" anchor="ctr"/>
-          <a:lstStyle/>
-          <a:p>
-            <a:pPr algn="ctr" indent="0" marL="0">
-              <a:buNone/>
-            </a:pPr>
-            <a:r>
-              <a:rPr lang="en-US" sz="1000" b="1" dirty="0">
-                <a:solidFill>
-                  <a:srgbClr val="FFFFFF"/>
-                </a:solidFill>
-              </a:rPr>
-              <a:t>7</a:t>
-            </a:r>
-            <a:endParaRPr lang="en-US" sz="1000" dirty="0"/>
-          </a:p>
-        </p:txBody>
-      </p:sp>
-      <p:sp>
-        <p:nvSpPr>
-          <p:cNvPr id="43" name="Text 41"/>
-          <p:cNvSpPr/>
-          <p:nvPr/>
-        </p:nvSpPr>
-        <p:spPr>
-          <a:xfrm>
-            <a:off x="5257800" y="2359152"/>
-            <a:ext cx="3474720" cy="228600"/>
-          </a:xfrm>
-          <a:prstGeom prst="rect">
-            <a:avLst/>
-          </a:prstGeom>
-          <a:noFill/>
-          <a:ln/>
-        </p:spPr>
-        <p:txBody>
-          <a:bodyPr wrap="square" rtlCol="0" anchor="ctr"/>
-          <a:lstStyle/>
-          <a:p>
-            <a:pPr indent="0" marL="0">
-              <a:buNone/>
-            </a:pPr>
-            <a:r>
-              <a:rPr lang="en-US" sz="1100" b="1" dirty="0">
-                <a:solidFill>
-                  <a:srgbClr val="E6EDF3"/>
-                </a:solidFill>
-              </a:rPr>
-              <a:t>[[nodiscard]]</a:t>
-            </a:r>
-            <a:endParaRPr lang="en-US" sz="1100" dirty="0"/>
-          </a:p>
-        </p:txBody>
-      </p:sp>
-      <p:sp>
-        <p:nvSpPr>
-          <p:cNvPr id="44" name="Text 42"/>
-          <p:cNvSpPr/>
-          <p:nvPr/>
-        </p:nvSpPr>
-        <p:spPr>
-          <a:xfrm>
-            <a:off x="5257800" y="2560320"/>
-            <a:ext cx="3474720" cy="182880"/>
-          </a:xfrm>
-          <a:prstGeom prst="rect">
-            <a:avLst/>
-          </a:prstGeom>
-          <a:noFill/>
-          <a:ln/>
-        </p:spPr>
-        <p:txBody>
-          <a:bodyPr wrap="square" rtlCol="0" anchor="ctr"/>
-          <a:lstStyle/>
-          <a:p>
-            <a:pPr indent="0" marL="0">
-              <a:buNone/>
-            </a:pPr>
-            <a:r>
-              <a:rPr lang="en-US" sz="800" dirty="0">
-                <a:solidFill>
-                  <a:srgbClr val="8B949E"/>
-                </a:solidFill>
-                <a:latin typeface="Courier New" pitchFamily="34" charset="0"/>
-                <a:ea typeface="Courier New" pitchFamily="34" charset="-122"/>
-                <a:cs typeface="Courier New" pitchFamily="34" charset="-120"/>
-              </a:rPr>
-              <a:t>Expected</a:t>
-            </a:r>
-            <a:endParaRPr lang="en-US" sz="800" dirty="0"/>
-          </a:p>
-        </p:txBody>
-      </p:sp>
-      <p:sp>
-        <p:nvSpPr>
-          <p:cNvPr id="45" name="Shape 43"/>
-          <p:cNvSpPr/>
-          <p:nvPr/>
-        </p:nvSpPr>
-        <p:spPr>
-          <a:xfrm>
-            <a:off x="4754880" y="2971800"/>
-            <a:ext cx="4206240" cy="502920"/>
-          </a:xfrm>
-          <a:prstGeom prst="rect">
-            <a:avLst/>
-          </a:prstGeom>
-          <a:solidFill>
-            <a:srgbClr val="161B22"/>
-          </a:solidFill>
-          <a:ln/>
-        </p:spPr>
-      </p:sp>
-      <p:sp>
-        <p:nvSpPr>
-          <p:cNvPr id="46" name="Shape 44"/>
-          <p:cNvSpPr/>
-          <p:nvPr/>
-        </p:nvSpPr>
-        <p:spPr>
-          <a:xfrm>
-            <a:off x="4754880" y="2971800"/>
-            <a:ext cx="27432" cy="502920"/>
-          </a:xfrm>
-          <a:prstGeom prst="rect">
-            <a:avLst/>
-          </a:prstGeom>
-          <a:solidFill>
-            <a:srgbClr val="8B949E"/>
-          </a:solidFill>
-          <a:ln/>
-        </p:spPr>
-      </p:sp>
-      <p:sp>
-        <p:nvSpPr>
-          <p:cNvPr id="47" name="Shape 45"/>
-          <p:cNvSpPr/>
-          <p:nvPr/>
-        </p:nvSpPr>
-        <p:spPr>
-          <a:xfrm>
-            <a:off x="4846320" y="3081528"/>
-            <a:ext cx="320040" cy="274320"/>
-          </a:xfrm>
-          <a:prstGeom prst="rect">
-            <a:avLst/>
-          </a:prstGeom>
-          <a:solidFill>
-            <a:srgbClr val="8B949E"/>
-          </a:solidFill>
-          <a:ln/>
-        </p:spPr>
-      </p:sp>
-      <p:sp>
-        <p:nvSpPr>
-          <p:cNvPr id="48" name="Text 46"/>
-          <p:cNvSpPr/>
-          <p:nvPr/>
-        </p:nvSpPr>
-        <p:spPr>
-          <a:xfrm>
-            <a:off x="4846320" y="3081528"/>
-            <a:ext cx="320040" cy="274320"/>
-          </a:xfrm>
-          <a:prstGeom prst="rect">
-            <a:avLst/>
-          </a:prstGeom>
-          <a:noFill/>
-          <a:ln/>
-        </p:spPr>
-        <p:txBody>
-          <a:bodyPr wrap="square" rtlCol="0" anchor="ctr"/>
-          <a:lstStyle/>
-          <a:p>
-            <a:pPr algn="ctr" indent="0" marL="0">
-              <a:buNone/>
-            </a:pPr>
-            <a:r>
-              <a:rPr lang="en-US" sz="1000" b="1" dirty="0">
-                <a:solidFill>
-                  <a:srgbClr val="FFFFFF"/>
-                </a:solidFill>
-              </a:rPr>
-              <a:t>8</a:t>
-            </a:r>
-            <a:endParaRPr lang="en-US" sz="1000" dirty="0"/>
-          </a:p>
-        </p:txBody>
-      </p:sp>
-      <p:sp>
-        <p:nvSpPr>
-          <p:cNvPr id="49" name="Text 47"/>
-          <p:cNvSpPr/>
-          <p:nvPr/>
-        </p:nvSpPr>
-        <p:spPr>
-          <a:xfrm>
-            <a:off x="5257800" y="3044952"/>
-            <a:ext cx="3474720" cy="228600"/>
-          </a:xfrm>
-          <a:prstGeom prst="rect">
-            <a:avLst/>
-          </a:prstGeom>
-          <a:noFill/>
-          <a:ln/>
-        </p:spPr>
-        <p:txBody>
-          <a:bodyPr wrap="square" rtlCol="0" anchor="ctr"/>
-          <a:lstStyle/>
-          <a:p>
-            <a:pPr indent="0" marL="0">
-              <a:buNone/>
-            </a:pPr>
-            <a:r>
-              <a:rPr lang="en-US" sz="1100" b="1" dirty="0">
-                <a:solidFill>
-                  <a:srgbClr val="E6EDF3"/>
-                </a:solidFill>
-              </a:rPr>
-              <a:t>Template Constraints</a:t>
-            </a:r>
-            <a:endParaRPr lang="en-US" sz="1100" dirty="0"/>
-          </a:p>
-        </p:txBody>
-      </p:sp>
-      <p:sp>
-        <p:nvSpPr>
-          <p:cNvPr id="50" name="Text 48"/>
-          <p:cNvSpPr/>
-          <p:nvPr/>
-        </p:nvSpPr>
-        <p:spPr>
-          <a:xfrm>
-            <a:off x="5257800" y="3246120"/>
-            <a:ext cx="3474720" cy="182880"/>
-          </a:xfrm>
-          <a:prstGeom prst="rect">
-            <a:avLst/>
-          </a:prstGeom>
-          <a:noFill/>
-          <a:ln/>
-        </p:spPr>
-        <p:txBody>
-          <a:bodyPr wrap="square" rtlCol="0" anchor="ctr"/>
-          <a:lstStyle/>
-          <a:p>
-            <a:pPr indent="0" marL="0">
-              <a:buNone/>
-            </a:pPr>
-            <a:r>
-              <a:rPr lang="en-US" sz="800" dirty="0">
-                <a:solidFill>
-                  <a:srgbClr val="8B949E"/>
-                </a:solidFill>
-                <a:latin typeface="Courier New" pitchFamily="34" charset="0"/>
-                <a:ea typeface="Courier New" pitchFamily="34" charset="-122"/>
-                <a:cs typeface="Courier New" pitchFamily="34" charset="-120"/>
-              </a:rPr>
-              <a:t>SFINAE / Concepts</a:t>
-            </a:r>
-            <a:endParaRPr lang="en-US" sz="800" dirty="0"/>
+          <p:cNvPr id="51" name="TextBox 50"/>
+          <p:cNvSpPr txBox="1"/>
+          <p:nvPr/>
+        </p:nvSpPr>
+        <p:spPr>
+          <a:xfrm>
+            <a:off x="457200" y="6217920"/>
+            <a:ext cx="8229600" cy="457200"/>
+          </a:xfrm>
+          <a:prstGeom prst="rect">
+            <a:avLst/>
+          </a:prstGeom>
+          <a:noFill/>
+        </p:spPr>
+        <p:txBody>
+          <a:bodyPr wrap="none">
+            <a:spAutoFit/>
+          </a:bodyPr>
+          <a:lstStyle/>
+          <a:p>
+            <a:pPr>
+              <a:defRPr sz="1400"/>
+            </a:pPr>
+            <a:r>
+              <a:t>Sessions 6–8 are optional extensions and are not included in this bundle.</a:t>
+            </a:r>
           </a:p>
         </p:txBody>
       </p:sp>
@@ -8163,4 +8389,319 @@
     </a:ext>
   </a:extLst>
 </a:theme>
+</file>
+
+<file path=ppt/theme/theme2.xml><?xml version="1.0" encoding="utf-8"?>
+<a:theme xmlns:a="http://schemas.openxmlformats.org/drawingml/2006/main" name="Office Theme">
+  <a:themeElements>
+    <a:clrScheme name="Office">
+      <a:dk1>
+        <a:sysClr val="windowText" lastClr="000000"/>
+      </a:dk1>
+      <a:lt1>
+        <a:sysClr val="window" lastClr="FFFFFF"/>
+      </a:lt1>
+      <a:dk2>
+        <a:srgbClr val="0E2841"/>
+      </a:dk2>
+      <a:lt2>
+        <a:srgbClr val="E8E8E8"/>
+      </a:lt2>
+      <a:accent1>
+        <a:srgbClr val="156082"/>
+      </a:accent1>
+      <a:accent2>
+        <a:srgbClr val="E97132"/>
+      </a:accent2>
+      <a:accent3>
+        <a:srgbClr val="196B24"/>
+      </a:accent3>
+      <a:accent4>
+        <a:srgbClr val="0F9ED5"/>
+      </a:accent4>
+      <a:accent5>
+        <a:srgbClr val="A02B93"/>
+      </a:accent5>
+      <a:accent6>
+        <a:srgbClr val="4EA72E"/>
+      </a:accent6>
+      <a:hlink>
+        <a:srgbClr val="467886"/>
+      </a:hlink>
+      <a:folHlink>
+        <a:srgbClr val="96607D"/>
+      </a:folHlink>
+    </a:clrScheme>
+    <a:fontScheme name="Office">
+      <a:majorFont>
+        <a:latin typeface="Aptos Display" panose="02110004020202020204"/>
+        <a:ea typeface=""/>
+        <a:cs typeface=""/>
+        <a:font script="Jpan" typeface="游ゴシック Light"/>
+        <a:font script="Hang" typeface="맑은 고딕"/>
+        <a:font script="Hans" typeface="等线 Light"/>
+        <a:font script="Hant" typeface="新細明體"/>
+        <a:font script="Arab" typeface="Times New Roman"/>
+        <a:font script="Hebr" typeface="Times New Roman"/>
+        <a:font script="Thai" typeface="Angsana New"/>
+        <a:font script="Ethi" typeface="Nyala"/>
+        <a:font script="Beng" typeface="Vrinda"/>
+        <a:font script="Gujr" typeface="Shruti"/>
+        <a:font script="Khmr" typeface="MoolBoran"/>
+        <a:font script="Knda" typeface="Tunga"/>
+        <a:font script="Guru" typeface="Raavi"/>
+        <a:font script="Cans" typeface="Euphemia"/>
+        <a:font script="Cher" typeface="Plantagenet Cherokee"/>
+        <a:font script="Yiii" typeface="Microsoft Yi Baiti"/>
+        <a:font script="Tibt" typeface="Microsoft Himalaya"/>
+        <a:font script="Thaa" typeface="MV Boli"/>
+        <a:font script="Deva" typeface="Mangal"/>
+        <a:font script="Telu" typeface="Gautami"/>
+        <a:font script="Taml" typeface="Latha"/>
+        <a:font script="Syrc" typeface="Estrangelo Edessa"/>
+        <a:font script="Orya" typeface="Kalinga"/>
+        <a:font script="Mlym" typeface="Kartika"/>
+        <a:font script="Laoo" typeface="DokChampa"/>
+        <a:font script="Sinh" typeface="Iskoola Pota"/>
+        <a:font script="Mong" typeface="Mongolian Baiti"/>
+        <a:font script="Viet" typeface="Times New Roman"/>
+        <a:font script="Uigh" typeface="Microsoft Uighur"/>
+        <a:font script="Geor" typeface="Sylfaen"/>
+        <a:font script="Armn" typeface="Arial"/>
+        <a:font script="Bugi" typeface="Leelawadee UI"/>
+        <a:font script="Bopo" typeface="Microsoft JhengHei"/>
+        <a:font script="Java" typeface="Javanese Text"/>
+        <a:font script="Lisu" typeface="Segoe UI"/>
+        <a:font script="Mymr" typeface="Myanmar Text"/>
+        <a:font script="Nkoo" typeface="Ebrima"/>
+        <a:font script="Olck" typeface="Nirmala UI"/>
+        <a:font script="Osma" typeface="Ebrima"/>
+        <a:font script="Phag" typeface="Phagspa"/>
+        <a:font script="Syrn" typeface="Estrangelo Edessa"/>
+        <a:font script="Syrj" typeface="Estrangelo Edessa"/>
+        <a:font script="Syre" typeface="Estrangelo Edessa"/>
+        <a:font script="Sora" typeface="Nirmala UI"/>
+        <a:font script="Tale" typeface="Microsoft Tai Le"/>
+        <a:font script="Talu" typeface="Microsoft New Tai Lue"/>
+        <a:font script="Tfng" typeface="Ebrima"/>
+      </a:majorFont>
+      <a:minorFont>
+        <a:latin typeface="Aptos" panose="02110004020202020204"/>
+        <a:ea typeface=""/>
+        <a:cs typeface=""/>
+        <a:font script="Jpan" typeface="游ゴシック"/>
+        <a:font script="Hang" typeface="맑은 고딕"/>
+        <a:font script="Hans" typeface="等线"/>
+        <a:font script="Hant" typeface="新細明體"/>
+        <a:font script="Arab" typeface="Arial"/>
+        <a:font script="Hebr" typeface="Arial"/>
+        <a:font script="Thai" typeface="Cordia New"/>
+        <a:font script="Ethi" typeface="Nyala"/>
+        <a:font script="Beng" typeface="Vrinda"/>
+        <a:font script="Gujr" typeface="Shruti"/>
+        <a:font script="Khmr" typeface="DaunPenh"/>
+        <a:font script="Knda" typeface="Tunga"/>
+        <a:font script="Guru" typeface="Raavi"/>
+        <a:font script="Cans" typeface="Euphemia"/>
+        <a:font script="Cher" typeface="Plantagenet Cherokee"/>
+        <a:font script="Yiii" typeface="Microsoft Yi Baiti"/>
+        <a:font script="Tibt" typeface="Microsoft Himalaya"/>
+        <a:font script="Thaa" typeface="MV Boli"/>
+        <a:font script="Deva" typeface="Mangal"/>
+        <a:font script="Telu" typeface="Gautami"/>
+        <a:font script="Taml" typeface="Latha"/>
+        <a:font script="Syrc" typeface="Estrangelo Edessa"/>
+        <a:font script="Orya" typeface="Kalinga"/>
+        <a:font script="Mlym" typeface="Kartika"/>
+        <a:font script="Laoo" typeface="DokChampa"/>
+        <a:font script="Sinh" typeface="Iskoola Pota"/>
+        <a:font script="Mong" typeface="Mongolian Baiti"/>
+        <a:font script="Viet" typeface="Arial"/>
+        <a:font script="Uigh" typeface="Microsoft Uighur"/>
+        <a:font script="Geor" typeface="Sylfaen"/>
+        <a:font script="Armn" typeface="Arial"/>
+        <a:font script="Bugi" typeface="Leelawadee UI"/>
+        <a:font script="Bopo" typeface="Microsoft JhengHei"/>
+        <a:font script="Java" typeface="Javanese Text"/>
+        <a:font script="Lisu" typeface="Segoe UI"/>
+        <a:font script="Mymr" typeface="Myanmar Text"/>
+        <a:font script="Nkoo" typeface="Ebrima"/>
+        <a:font script="Olck" typeface="Nirmala UI"/>
+        <a:font script="Osma" typeface="Ebrima"/>
+        <a:font script="Phag" typeface="Phagspa"/>
+        <a:font script="Syrn" typeface="Estrangelo Edessa"/>
+        <a:font script="Syrj" typeface="Estrangelo Edessa"/>
+        <a:font script="Syre" typeface="Estrangelo Edessa"/>
+        <a:font script="Sora" typeface="Nirmala UI"/>
+        <a:font script="Tale" typeface="Microsoft Tai Le"/>
+        <a:font script="Talu" typeface="Microsoft New Tai Lue"/>
+        <a:font script="Tfng" typeface="Ebrima"/>
+      </a:minorFont>
+    </a:fontScheme>
+    <a:fmtScheme name="Office">
+      <a:fillStyleLst>
+        <a:solidFill>
+          <a:schemeClr val="phClr"/>
+        </a:solidFill>
+        <a:gradFill rotWithShape="1">
+          <a:gsLst>
+            <a:gs pos="0">
+              <a:schemeClr val="phClr">
+                <a:lumMod val="110000"/>
+                <a:satMod val="105000"/>
+                <a:tint val="67000"/>
+              </a:schemeClr>
+            </a:gs>
+            <a:gs pos="50000">
+              <a:schemeClr val="phClr">
+                <a:lumMod val="105000"/>
+                <a:satMod val="103000"/>
+                <a:tint val="73000"/>
+              </a:schemeClr>
+            </a:gs>
+            <a:gs pos="100000">
+              <a:schemeClr val="phClr">
+                <a:lumMod val="105000"/>
+                <a:satMod val="109000"/>
+                <a:tint val="81000"/>
+              </a:schemeClr>
+            </a:gs>
+          </a:gsLst>
+          <a:lin ang="5400000" scaled="0"/>
+        </a:gradFill>
+        <a:gradFill rotWithShape="1">
+          <a:gsLst>
+            <a:gs pos="0">
+              <a:schemeClr val="phClr">
+                <a:satMod val="103000"/>
+                <a:lumMod val="102000"/>
+                <a:tint val="94000"/>
+              </a:schemeClr>
+            </a:gs>
+            <a:gs pos="50000">
+              <a:schemeClr val="phClr">
+                <a:satMod val="110000"/>
+                <a:lumMod val="100000"/>
+                <a:shade val="100000"/>
+              </a:schemeClr>
+            </a:gs>
+            <a:gs pos="100000">
+              <a:schemeClr val="phClr">
+                <a:lumMod val="99000"/>
+                <a:satMod val="120000"/>
+                <a:shade val="78000"/>
+              </a:schemeClr>
+            </a:gs>
+          </a:gsLst>
+          <a:lin ang="5400000" scaled="0"/>
+        </a:gradFill>
+      </a:fillStyleLst>
+      <a:lnStyleLst>
+        <a:ln w="12700" cap="flat" cmpd="sng" algn="ctr">
+          <a:solidFill>
+            <a:schemeClr val="phClr"/>
+          </a:solidFill>
+          <a:prstDash val="solid"/>
+          <a:miter lim="800000"/>
+        </a:ln>
+        <a:ln w="19050" cap="flat" cmpd="sng" algn="ctr">
+          <a:solidFill>
+            <a:schemeClr val="phClr"/>
+          </a:solidFill>
+          <a:prstDash val="solid"/>
+          <a:miter lim="800000"/>
+        </a:ln>
+        <a:ln w="25400" cap="flat" cmpd="sng" algn="ctr">
+          <a:solidFill>
+            <a:schemeClr val="phClr"/>
+          </a:solidFill>
+          <a:prstDash val="solid"/>
+          <a:miter lim="800000"/>
+        </a:ln>
+      </a:lnStyleLst>
+      <a:effectStyleLst>
+        <a:effectStyle>
+          <a:effectLst/>
+        </a:effectStyle>
+        <a:effectStyle>
+          <a:effectLst/>
+        </a:effectStyle>
+        <a:effectStyle>
+          <a:effectLst>
+            <a:outerShdw blurRad="57150" dist="19050" dir="5400000" algn="ctr" rotWithShape="0">
+              <a:srgbClr val="000000">
+                <a:alpha val="63000"/>
+              </a:srgbClr>
+            </a:outerShdw>
+          </a:effectLst>
+        </a:effectStyle>
+      </a:effectStyleLst>
+      <a:bgFillStyleLst>
+        <a:solidFill>
+          <a:schemeClr val="phClr"/>
+        </a:solidFill>
+        <a:solidFill>
+          <a:schemeClr val="phClr">
+            <a:tint val="95000"/>
+            <a:satMod val="170000"/>
+          </a:schemeClr>
+        </a:solidFill>
+        <a:gradFill rotWithShape="1">
+          <a:gsLst>
+            <a:gs pos="0">
+              <a:schemeClr val="phClr">
+                <a:tint val="93000"/>
+                <a:satMod val="150000"/>
+                <a:shade val="98000"/>
+                <a:lumMod val="102000"/>
+              </a:schemeClr>
+            </a:gs>
+            <a:gs pos="50000">
+              <a:schemeClr val="phClr">
+                <a:tint val="98000"/>
+                <a:satMod val="130000"/>
+                <a:shade val="90000"/>
+                <a:lumMod val="103000"/>
+              </a:schemeClr>
+            </a:gs>
+            <a:gs pos="100000">
+              <a:schemeClr val="phClr">
+                <a:shade val="63000"/>
+                <a:satMod val="120000"/>
+              </a:schemeClr>
+            </a:gs>
+          </a:gsLst>
+          <a:lin ang="5400000" scaled="0"/>
+        </a:gradFill>
+      </a:bgFillStyleLst>
+    </a:fmtScheme>
+  </a:themeElements>
+  <a:objectDefaults>
+    <a:lnDef>
+      <a:spPr/>
+      <a:bodyPr/>
+      <a:lstStyle/>
+      <a:style>
+        <a:lnRef idx="2">
+          <a:schemeClr val="accent1"/>
+        </a:lnRef>
+        <a:fillRef idx="0">
+          <a:schemeClr val="accent1"/>
+        </a:fillRef>
+        <a:effectRef idx="1">
+          <a:schemeClr val="accent1"/>
+        </a:effectRef>
+        <a:fontRef idx="minor">
+          <a:schemeClr val="tx1"/>
+        </a:fontRef>
+      </a:style>
+    </a:lnDef>
+  </a:objectDefaults>
+  <a:extraClrSchemeLst/>
+  <a:extLst>
+    <a:ext uri="{05A4C25C-085E-4340-85A3-A5531E510DB2}">
+      <thm15:themeFamily xmlns:thm15="http://schemas.microsoft.com/office/thememl/2012/main" name="Office Theme" id="{2E142A2C-CD16-42D6-873A-C26D2A0506FA}" vid="{1BDDFF52-6CD6-40A5-AB3C-68EB2F1E4D0A}"/>
+    </a:ext>
+  </a:extLst>
+</a:theme>
 </file>
</xml_diff>